<commit_message>
Added in rental  item
</commit_message>
<xml_diff>
--- a/CameraKit Walkthrough.pptx
+++ b/CameraKit Walkthrough.pptx
@@ -37,6 +37,17 @@
     <p:sldId id="277" r:id="rId31"/>
     <p:sldId id="279" r:id="rId32"/>
     <p:sldId id="280" r:id="rId33"/>
+    <p:sldId id="288" r:id="rId34"/>
+    <p:sldId id="289" r:id="rId35"/>
+    <p:sldId id="290" r:id="rId36"/>
+    <p:sldId id="291" r:id="rId37"/>
+    <p:sldId id="292" r:id="rId38"/>
+    <p:sldId id="293" r:id="rId39"/>
+    <p:sldId id="294" r:id="rId40"/>
+    <p:sldId id="295" r:id="rId41"/>
+    <p:sldId id="296" r:id="rId42"/>
+    <p:sldId id="297" r:id="rId43"/>
+    <p:sldId id="298" r:id="rId44"/>
   </p:sldIdLst>
   <p:sldSz cx="12192000" cy="6858000"/>
   <p:notesSz cx="6858000" cy="9144000"/>
@@ -292,7 +303,7 @@
           <a:p>
             <a:fld id="{56BB6EC9-C718-4390-853C-59E596581ED2}" type="datetimeFigureOut">
               <a:rPr lang="en-IE" smtClean="0"/>
-              <a:t>11/11/2025</a:t>
+              <a:t>18/11/2025</a:t>
             </a:fld>
             <a:endParaRPr lang="en-IE"/>
           </a:p>
@@ -492,7 +503,7 @@
           <a:p>
             <a:fld id="{56BB6EC9-C718-4390-853C-59E596581ED2}" type="datetimeFigureOut">
               <a:rPr lang="en-IE" smtClean="0"/>
-              <a:t>11/11/2025</a:t>
+              <a:t>18/11/2025</a:t>
             </a:fld>
             <a:endParaRPr lang="en-IE"/>
           </a:p>
@@ -702,7 +713,7 @@
           <a:p>
             <a:fld id="{56BB6EC9-C718-4390-853C-59E596581ED2}" type="datetimeFigureOut">
               <a:rPr lang="en-IE" smtClean="0"/>
-              <a:t>11/11/2025</a:t>
+              <a:t>18/11/2025</a:t>
             </a:fld>
             <a:endParaRPr lang="en-IE"/>
           </a:p>
@@ -902,7 +913,7 @@
           <a:p>
             <a:fld id="{56BB6EC9-C718-4390-853C-59E596581ED2}" type="datetimeFigureOut">
               <a:rPr lang="en-IE" smtClean="0"/>
-              <a:t>11/11/2025</a:t>
+              <a:t>18/11/2025</a:t>
             </a:fld>
             <a:endParaRPr lang="en-IE"/>
           </a:p>
@@ -1178,7 +1189,7 @@
           <a:p>
             <a:fld id="{56BB6EC9-C718-4390-853C-59E596581ED2}" type="datetimeFigureOut">
               <a:rPr lang="en-IE" smtClean="0"/>
-              <a:t>11/11/2025</a:t>
+              <a:t>18/11/2025</a:t>
             </a:fld>
             <a:endParaRPr lang="en-IE"/>
           </a:p>
@@ -1446,7 +1457,7 @@
           <a:p>
             <a:fld id="{56BB6EC9-C718-4390-853C-59E596581ED2}" type="datetimeFigureOut">
               <a:rPr lang="en-IE" smtClean="0"/>
-              <a:t>11/11/2025</a:t>
+              <a:t>18/11/2025</a:t>
             </a:fld>
             <a:endParaRPr lang="en-IE"/>
           </a:p>
@@ -1861,7 +1872,7 @@
           <a:p>
             <a:fld id="{56BB6EC9-C718-4390-853C-59E596581ED2}" type="datetimeFigureOut">
               <a:rPr lang="en-IE" smtClean="0"/>
-              <a:t>11/11/2025</a:t>
+              <a:t>18/11/2025</a:t>
             </a:fld>
             <a:endParaRPr lang="en-IE"/>
           </a:p>
@@ -2003,7 +2014,7 @@
           <a:p>
             <a:fld id="{56BB6EC9-C718-4390-853C-59E596581ED2}" type="datetimeFigureOut">
               <a:rPr lang="en-IE" smtClean="0"/>
-              <a:t>11/11/2025</a:t>
+              <a:t>18/11/2025</a:t>
             </a:fld>
             <a:endParaRPr lang="en-IE"/>
           </a:p>
@@ -2116,7 +2127,7 @@
           <a:p>
             <a:fld id="{56BB6EC9-C718-4390-853C-59E596581ED2}" type="datetimeFigureOut">
               <a:rPr lang="en-IE" smtClean="0"/>
-              <a:t>11/11/2025</a:t>
+              <a:t>18/11/2025</a:t>
             </a:fld>
             <a:endParaRPr lang="en-IE"/>
           </a:p>
@@ -2429,7 +2440,7 @@
           <a:p>
             <a:fld id="{56BB6EC9-C718-4390-853C-59E596581ED2}" type="datetimeFigureOut">
               <a:rPr lang="en-IE" smtClean="0"/>
-              <a:t>11/11/2025</a:t>
+              <a:t>18/11/2025</a:t>
             </a:fld>
             <a:endParaRPr lang="en-IE"/>
           </a:p>
@@ -2718,7 +2729,7 @@
           <a:p>
             <a:fld id="{56BB6EC9-C718-4390-853C-59E596581ED2}" type="datetimeFigureOut">
               <a:rPr lang="en-IE" smtClean="0"/>
-              <a:t>11/11/2025</a:t>
+              <a:t>18/11/2025</a:t>
             </a:fld>
             <a:endParaRPr lang="en-IE"/>
           </a:p>
@@ -2961,7 +2972,7 @@
           <a:p>
             <a:fld id="{56BB6EC9-C718-4390-853C-59E596581ED2}" type="datetimeFigureOut">
               <a:rPr lang="en-IE" smtClean="0"/>
-              <a:t>11/11/2025</a:t>
+              <a:t>18/11/2025</a:t>
             </a:fld>
             <a:endParaRPr lang="en-IE"/>
           </a:p>
@@ -3426,12 +3437,20 @@
             <p:ph type="subTitle" idx="1"/>
           </p:nvPr>
         </p:nvSpPr>
-        <p:spPr/>
+        <p:spPr>
+          <a:xfrm>
+            <a:off x="0" y="3602038"/>
+            <a:ext cx="12192000" cy="1655762"/>
+          </a:xfrm>
+        </p:spPr>
         <p:txBody>
           <a:bodyPr/>
           <a:lstStyle/>
           <a:p>
-            <a:endParaRPr lang="en-IE"/>
+            <a:r>
+              <a:rPr lang="en-IE" dirty="0"/>
+              <a:t>https://github.com/JohnRowleyDorsetCollege2025/oop-2025-a-camera-rental-20251111.git</a:t>
+            </a:r>
           </a:p>
         </p:txBody>
       </p:sp>
@@ -6221,6 +6240,917 @@
 </p:sld>
 </file>
 
+<file path=ppt/slides/slide33.xml><?xml version="1.0" encoding="utf-8"?>
+<p:sld xmlns:a="http://schemas.openxmlformats.org/drawingml/2006/main" xmlns:r="http://schemas.openxmlformats.org/officeDocument/2006/relationships" xmlns:p="http://schemas.openxmlformats.org/presentationml/2006/main">
+  <p:cSld>
+    <p:spTree>
+      <p:nvGrpSpPr>
+        <p:cNvPr id="1" name=""/>
+        <p:cNvGrpSpPr/>
+        <p:nvPr/>
+      </p:nvGrpSpPr>
+      <p:grpSpPr>
+        <a:xfrm>
+          <a:off x="0" y="0"/>
+          <a:ext cx="0" cy="0"/>
+          <a:chOff x="0" y="0"/>
+          <a:chExt cx="0" cy="0"/>
+        </a:xfrm>
+      </p:grpSpPr>
+      <p:sp>
+        <p:nvSpPr>
+          <p:cNvPr id="2" name="Title 1">
+            <a:extLst>
+              <a:ext uri="{FF2B5EF4-FFF2-40B4-BE49-F238E27FC236}">
+                <a16:creationId xmlns:a16="http://schemas.microsoft.com/office/drawing/2014/main" id="{A34B4CAC-CD86-DAA4-61EB-4FBAF5A12DBB}"/>
+              </a:ext>
+            </a:extLst>
+          </p:cNvPr>
+          <p:cNvSpPr>
+            <a:spLocks noGrp="1"/>
+          </p:cNvSpPr>
+          <p:nvPr>
+            <p:ph type="title"/>
+          </p:nvPr>
+        </p:nvSpPr>
+        <p:spPr/>
+        <p:txBody>
+          <a:bodyPr/>
+          <a:lstStyle/>
+          <a:p>
+            <a:r>
+              <a:rPr lang="en-GB" dirty="0"/>
+              <a:t>Interfaces, abstract classes</a:t>
+            </a:r>
+          </a:p>
+        </p:txBody>
+      </p:sp>
+      <p:sp>
+        <p:nvSpPr>
+          <p:cNvPr id="3" name="Text Placeholder 2">
+            <a:extLst>
+              <a:ext uri="{FF2B5EF4-FFF2-40B4-BE49-F238E27FC236}">
+                <a16:creationId xmlns:a16="http://schemas.microsoft.com/office/drawing/2014/main" id="{3CB5371B-AA99-D482-F471-BC3616BDE8BF}"/>
+              </a:ext>
+            </a:extLst>
+          </p:cNvPr>
+          <p:cNvSpPr>
+            <a:spLocks noGrp="1"/>
+          </p:cNvSpPr>
+          <p:nvPr>
+            <p:ph type="body" idx="1"/>
+          </p:nvPr>
+        </p:nvSpPr>
+        <p:spPr/>
+        <p:txBody>
+          <a:bodyPr/>
+          <a:lstStyle/>
+          <a:p>
+            <a:endParaRPr lang="en-GB" dirty="0"/>
+          </a:p>
+        </p:txBody>
+      </p:sp>
+    </p:spTree>
+    <p:extLst>
+      <p:ext uri="{BB962C8B-B14F-4D97-AF65-F5344CB8AC3E}">
+        <p14:creationId xmlns:p14="http://schemas.microsoft.com/office/powerpoint/2010/main" val="1665354833"/>
+      </p:ext>
+    </p:extLst>
+  </p:cSld>
+  <p:clrMapOvr>
+    <a:masterClrMapping/>
+  </p:clrMapOvr>
+</p:sld>
+</file>
+
+<file path=ppt/slides/slide34.xml><?xml version="1.0" encoding="utf-8"?>
+<p:sld xmlns:a="http://schemas.openxmlformats.org/drawingml/2006/main" xmlns:r="http://schemas.openxmlformats.org/officeDocument/2006/relationships" xmlns:p="http://schemas.openxmlformats.org/presentationml/2006/main">
+  <p:cSld>
+    <p:spTree>
+      <p:nvGrpSpPr>
+        <p:cNvPr id="1" name=""/>
+        <p:cNvGrpSpPr/>
+        <p:nvPr/>
+      </p:nvGrpSpPr>
+      <p:grpSpPr>
+        <a:xfrm>
+          <a:off x="0" y="0"/>
+          <a:ext cx="0" cy="0"/>
+          <a:chOff x="0" y="0"/>
+          <a:chExt cx="0" cy="0"/>
+        </a:xfrm>
+      </p:grpSpPr>
+      <p:pic>
+        <p:nvPicPr>
+          <p:cNvPr id="5" name="Picture 4">
+            <a:extLst>
+              <a:ext uri="{FF2B5EF4-FFF2-40B4-BE49-F238E27FC236}">
+                <a16:creationId xmlns:a16="http://schemas.microsoft.com/office/drawing/2014/main" id="{B6852D04-424B-4CDA-A6C7-B0CAE8294408}"/>
+              </a:ext>
+            </a:extLst>
+          </p:cNvPr>
+          <p:cNvPicPr>
+            <a:picLocks noChangeAspect="1"/>
+          </p:cNvPicPr>
+          <p:nvPr/>
+        </p:nvPicPr>
+        <p:blipFill>
+          <a:blip r:embed="rId2"/>
+          <a:stretch>
+            <a:fillRect/>
+          </a:stretch>
+        </p:blipFill>
+        <p:spPr>
+          <a:xfrm>
+            <a:off x="1071097" y="1272684"/>
+            <a:ext cx="10357816" cy="4158625"/>
+          </a:xfrm>
+          <a:prstGeom prst="rect">
+            <a:avLst/>
+          </a:prstGeom>
+        </p:spPr>
+      </p:pic>
+      <p:sp>
+        <p:nvSpPr>
+          <p:cNvPr id="6" name="Rectangle 5">
+            <a:extLst>
+              <a:ext uri="{FF2B5EF4-FFF2-40B4-BE49-F238E27FC236}">
+                <a16:creationId xmlns:a16="http://schemas.microsoft.com/office/drawing/2014/main" id="{232796C3-116F-516A-5722-E4CE3AF1F566}"/>
+              </a:ext>
+            </a:extLst>
+          </p:cNvPr>
+          <p:cNvSpPr/>
+          <p:nvPr/>
+        </p:nvSpPr>
+        <p:spPr>
+          <a:xfrm>
+            <a:off x="2242686" y="1366787"/>
+            <a:ext cx="1337912" cy="442762"/>
+          </a:xfrm>
+          <a:prstGeom prst="rect">
+            <a:avLst/>
+          </a:prstGeom>
+          <a:noFill/>
+        </p:spPr>
+        <p:style>
+          <a:lnRef idx="2">
+            <a:schemeClr val="accent1">
+              <a:shade val="15000"/>
+            </a:schemeClr>
+          </a:lnRef>
+          <a:fillRef idx="1">
+            <a:schemeClr val="accent1"/>
+          </a:fillRef>
+          <a:effectRef idx="0">
+            <a:schemeClr val="accent1"/>
+          </a:effectRef>
+          <a:fontRef idx="minor">
+            <a:schemeClr val="lt1"/>
+          </a:fontRef>
+        </p:style>
+        <p:txBody>
+          <a:bodyPr rtlCol="0" anchor="ctr"/>
+          <a:lstStyle/>
+          <a:p>
+            <a:pPr algn="ctr"/>
+            <a:endParaRPr lang="en-GB"/>
+          </a:p>
+        </p:txBody>
+      </p:sp>
+    </p:spTree>
+    <p:extLst>
+      <p:ext uri="{BB962C8B-B14F-4D97-AF65-F5344CB8AC3E}">
+        <p14:creationId xmlns:p14="http://schemas.microsoft.com/office/powerpoint/2010/main" val="413122751"/>
+      </p:ext>
+    </p:extLst>
+  </p:cSld>
+  <p:clrMapOvr>
+    <a:masterClrMapping/>
+  </p:clrMapOvr>
+</p:sld>
+</file>
+
+<file path=ppt/slides/slide35.xml><?xml version="1.0" encoding="utf-8"?>
+<p:sld xmlns:a="http://schemas.openxmlformats.org/drawingml/2006/main" xmlns:r="http://schemas.openxmlformats.org/officeDocument/2006/relationships" xmlns:p="http://schemas.openxmlformats.org/presentationml/2006/main">
+  <p:cSld>
+    <p:spTree>
+      <p:nvGrpSpPr>
+        <p:cNvPr id="1" name=""/>
+        <p:cNvGrpSpPr/>
+        <p:nvPr/>
+      </p:nvGrpSpPr>
+      <p:grpSpPr>
+        <a:xfrm>
+          <a:off x="0" y="0"/>
+          <a:ext cx="0" cy="0"/>
+          <a:chOff x="0" y="0"/>
+          <a:chExt cx="0" cy="0"/>
+        </a:xfrm>
+      </p:grpSpPr>
+      <p:pic>
+        <p:nvPicPr>
+          <p:cNvPr id="5" name="Picture 4">
+            <a:extLst>
+              <a:ext uri="{FF2B5EF4-FFF2-40B4-BE49-F238E27FC236}">
+                <a16:creationId xmlns:a16="http://schemas.microsoft.com/office/drawing/2014/main" id="{3A4A5351-59E1-EEE7-F7DE-B2E5C355C7F2}"/>
+              </a:ext>
+            </a:extLst>
+          </p:cNvPr>
+          <p:cNvPicPr>
+            <a:picLocks noChangeAspect="1"/>
+          </p:cNvPicPr>
+          <p:nvPr/>
+        </p:nvPicPr>
+        <p:blipFill>
+          <a:blip r:embed="rId2"/>
+          <a:stretch>
+            <a:fillRect/>
+          </a:stretch>
+        </p:blipFill>
+        <p:spPr>
+          <a:xfrm>
+            <a:off x="288892" y="258471"/>
+            <a:ext cx="11532978" cy="5795820"/>
+          </a:xfrm>
+          <a:prstGeom prst="rect">
+            <a:avLst/>
+          </a:prstGeom>
+        </p:spPr>
+      </p:pic>
+    </p:spTree>
+    <p:extLst>
+      <p:ext uri="{BB962C8B-B14F-4D97-AF65-F5344CB8AC3E}">
+        <p14:creationId xmlns:p14="http://schemas.microsoft.com/office/powerpoint/2010/main" val="1297244950"/>
+      </p:ext>
+    </p:extLst>
+  </p:cSld>
+  <p:clrMapOvr>
+    <a:masterClrMapping/>
+  </p:clrMapOvr>
+</p:sld>
+</file>
+
+<file path=ppt/slides/slide36.xml><?xml version="1.0" encoding="utf-8"?>
+<p:sld xmlns:a="http://schemas.openxmlformats.org/drawingml/2006/main" xmlns:r="http://schemas.openxmlformats.org/officeDocument/2006/relationships" xmlns:p="http://schemas.openxmlformats.org/presentationml/2006/main">
+  <p:cSld>
+    <p:spTree>
+      <p:nvGrpSpPr>
+        <p:cNvPr id="1" name=""/>
+        <p:cNvGrpSpPr/>
+        <p:nvPr/>
+      </p:nvGrpSpPr>
+      <p:grpSpPr>
+        <a:xfrm>
+          <a:off x="0" y="0"/>
+          <a:ext cx="0" cy="0"/>
+          <a:chOff x="0" y="0"/>
+          <a:chExt cx="0" cy="0"/>
+        </a:xfrm>
+      </p:grpSpPr>
+      <p:pic>
+        <p:nvPicPr>
+          <p:cNvPr id="5" name="Picture 4">
+            <a:extLst>
+              <a:ext uri="{FF2B5EF4-FFF2-40B4-BE49-F238E27FC236}">
+                <a16:creationId xmlns:a16="http://schemas.microsoft.com/office/drawing/2014/main" id="{139D0F41-2BCE-4CFA-3F27-BADC2FFC52E3}"/>
+              </a:ext>
+            </a:extLst>
+          </p:cNvPr>
+          <p:cNvPicPr>
+            <a:picLocks noChangeAspect="1"/>
+          </p:cNvPicPr>
+          <p:nvPr/>
+        </p:nvPicPr>
+        <p:blipFill>
+          <a:blip r:embed="rId2"/>
+          <a:srcRect r="22711"/>
+          <a:stretch>
+            <a:fillRect/>
+          </a:stretch>
+        </p:blipFill>
+        <p:spPr>
+          <a:xfrm>
+            <a:off x="0" y="2221598"/>
+            <a:ext cx="11838591" cy="3033795"/>
+          </a:xfrm>
+          <a:prstGeom prst="rect">
+            <a:avLst/>
+          </a:prstGeom>
+        </p:spPr>
+      </p:pic>
+      <p:cxnSp>
+        <p:nvCxnSpPr>
+          <p:cNvPr id="7" name="Straight Arrow Connector 6">
+            <a:extLst>
+              <a:ext uri="{FF2B5EF4-FFF2-40B4-BE49-F238E27FC236}">
+                <a16:creationId xmlns:a16="http://schemas.microsoft.com/office/drawing/2014/main" id="{5BCEEA32-8AE9-45C7-B0D3-916E6FA72FA7}"/>
+              </a:ext>
+            </a:extLst>
+          </p:cNvPr>
+          <p:cNvCxnSpPr/>
+          <p:nvPr/>
+        </p:nvCxnSpPr>
+        <p:spPr>
+          <a:xfrm flipH="1">
+            <a:off x="8142973" y="1443789"/>
+            <a:ext cx="962526" cy="1780674"/>
+          </a:xfrm>
+          <a:prstGeom prst="straightConnector1">
+            <a:avLst/>
+          </a:prstGeom>
+          <a:ln>
+            <a:tailEnd type="triangle"/>
+          </a:ln>
+        </p:spPr>
+        <p:style>
+          <a:lnRef idx="1">
+            <a:schemeClr val="accent1"/>
+          </a:lnRef>
+          <a:fillRef idx="0">
+            <a:schemeClr val="accent1"/>
+          </a:fillRef>
+          <a:effectRef idx="0">
+            <a:schemeClr val="accent1"/>
+          </a:effectRef>
+          <a:fontRef idx="minor">
+            <a:schemeClr val="tx1"/>
+          </a:fontRef>
+        </p:style>
+      </p:cxnSp>
+      <p:sp>
+        <p:nvSpPr>
+          <p:cNvPr id="8" name="Rectangle 7">
+            <a:extLst>
+              <a:ext uri="{FF2B5EF4-FFF2-40B4-BE49-F238E27FC236}">
+                <a16:creationId xmlns:a16="http://schemas.microsoft.com/office/drawing/2014/main" id="{8D12BD08-4843-3D98-A10C-FB5EF4B87A19}"/>
+              </a:ext>
+            </a:extLst>
+          </p:cNvPr>
+          <p:cNvSpPr/>
+          <p:nvPr/>
+        </p:nvSpPr>
+        <p:spPr>
+          <a:xfrm>
+            <a:off x="6517345" y="376588"/>
+            <a:ext cx="4598793" cy="970737"/>
+          </a:xfrm>
+          <a:prstGeom prst="rect">
+            <a:avLst/>
+          </a:prstGeom>
+          <a:solidFill>
+            <a:schemeClr val="accent4">
+              <a:lumMod val="40000"/>
+              <a:lumOff val="60000"/>
+            </a:schemeClr>
+          </a:solidFill>
+        </p:spPr>
+        <p:style>
+          <a:lnRef idx="2">
+            <a:schemeClr val="accent1">
+              <a:shade val="50000"/>
+            </a:schemeClr>
+          </a:lnRef>
+          <a:fillRef idx="1">
+            <a:schemeClr val="accent1"/>
+          </a:fillRef>
+          <a:effectRef idx="0">
+            <a:schemeClr val="accent1"/>
+          </a:effectRef>
+          <a:fontRef idx="minor">
+            <a:schemeClr val="lt1"/>
+          </a:fontRef>
+        </p:style>
+        <p:txBody>
+          <a:bodyPr rtlCol="0" anchor="ctr"/>
+          <a:lstStyle/>
+          <a:p>
+            <a:pPr algn="ctr"/>
+            <a:r>
+              <a:rPr lang="en-IE" dirty="0">
+                <a:solidFill>
+                  <a:schemeClr val="tx1"/>
+                </a:solidFill>
+              </a:rPr>
+              <a:t>Constructors passes parameters back to base / abstract class</a:t>
+            </a:r>
+          </a:p>
+        </p:txBody>
+      </p:sp>
+      <p:sp>
+        <p:nvSpPr>
+          <p:cNvPr id="9" name="Rectangle 8">
+            <a:extLst>
+              <a:ext uri="{FF2B5EF4-FFF2-40B4-BE49-F238E27FC236}">
+                <a16:creationId xmlns:a16="http://schemas.microsoft.com/office/drawing/2014/main" id="{7822A24E-A95F-B722-DC7D-48C429948DB1}"/>
+              </a:ext>
+            </a:extLst>
+          </p:cNvPr>
+          <p:cNvSpPr/>
+          <p:nvPr/>
+        </p:nvSpPr>
+        <p:spPr>
+          <a:xfrm>
+            <a:off x="721333" y="2752825"/>
+            <a:ext cx="4598793" cy="385010"/>
+          </a:xfrm>
+          <a:prstGeom prst="rect">
+            <a:avLst/>
+          </a:prstGeom>
+          <a:solidFill>
+            <a:schemeClr val="accent4">
+              <a:lumMod val="40000"/>
+              <a:lumOff val="60000"/>
+            </a:schemeClr>
+          </a:solidFill>
+        </p:spPr>
+        <p:style>
+          <a:lnRef idx="2">
+            <a:schemeClr val="accent1">
+              <a:shade val="50000"/>
+            </a:schemeClr>
+          </a:lnRef>
+          <a:fillRef idx="1">
+            <a:schemeClr val="accent1"/>
+          </a:fillRef>
+          <a:effectRef idx="0">
+            <a:schemeClr val="accent1"/>
+          </a:effectRef>
+          <a:fontRef idx="minor">
+            <a:schemeClr val="lt1"/>
+          </a:fontRef>
+        </p:style>
+        <p:txBody>
+          <a:bodyPr rtlCol="0" anchor="ctr"/>
+          <a:lstStyle/>
+          <a:p>
+            <a:pPr algn="ctr"/>
+            <a:r>
+              <a:rPr lang="en-IE" dirty="0">
+                <a:solidFill>
+                  <a:schemeClr val="tx1"/>
+                </a:solidFill>
+              </a:rPr>
+              <a:t>Removed original constructor</a:t>
+            </a:r>
+          </a:p>
+        </p:txBody>
+      </p:sp>
+    </p:spTree>
+    <p:extLst>
+      <p:ext uri="{BB962C8B-B14F-4D97-AF65-F5344CB8AC3E}">
+        <p14:creationId xmlns:p14="http://schemas.microsoft.com/office/powerpoint/2010/main" val="320270045"/>
+      </p:ext>
+    </p:extLst>
+  </p:cSld>
+  <p:clrMapOvr>
+    <a:masterClrMapping/>
+  </p:clrMapOvr>
+</p:sld>
+</file>
+
+<file path=ppt/slides/slide37.xml><?xml version="1.0" encoding="utf-8"?>
+<p:sld xmlns:a="http://schemas.openxmlformats.org/drawingml/2006/main" xmlns:r="http://schemas.openxmlformats.org/officeDocument/2006/relationships" xmlns:p="http://schemas.openxmlformats.org/presentationml/2006/main">
+  <p:cSld>
+    <p:spTree>
+      <p:nvGrpSpPr>
+        <p:cNvPr id="1" name=""/>
+        <p:cNvGrpSpPr/>
+        <p:nvPr/>
+      </p:nvGrpSpPr>
+      <p:grpSpPr>
+        <a:xfrm>
+          <a:off x="0" y="0"/>
+          <a:ext cx="0" cy="0"/>
+          <a:chOff x="0" y="0"/>
+          <a:chExt cx="0" cy="0"/>
+        </a:xfrm>
+      </p:grpSpPr>
+      <p:pic>
+        <p:nvPicPr>
+          <p:cNvPr id="5" name="Picture 4">
+            <a:extLst>
+              <a:ext uri="{FF2B5EF4-FFF2-40B4-BE49-F238E27FC236}">
+                <a16:creationId xmlns:a16="http://schemas.microsoft.com/office/drawing/2014/main" id="{CCE872A0-DE02-0E89-6C3F-8E79EFD600CF}"/>
+              </a:ext>
+            </a:extLst>
+          </p:cNvPr>
+          <p:cNvPicPr>
+            <a:picLocks noChangeAspect="1"/>
+          </p:cNvPicPr>
+          <p:nvPr/>
+        </p:nvPicPr>
+        <p:blipFill>
+          <a:blip r:embed="rId2"/>
+          <a:stretch>
+            <a:fillRect/>
+          </a:stretch>
+        </p:blipFill>
+        <p:spPr>
+          <a:xfrm>
+            <a:off x="477516" y="1087861"/>
+            <a:ext cx="5019048" cy="4104762"/>
+          </a:xfrm>
+          <a:prstGeom prst="rect">
+            <a:avLst/>
+          </a:prstGeom>
+        </p:spPr>
+      </p:pic>
+      <p:sp>
+        <p:nvSpPr>
+          <p:cNvPr id="6" name="Rectangle 5">
+            <a:extLst>
+              <a:ext uri="{FF2B5EF4-FFF2-40B4-BE49-F238E27FC236}">
+                <a16:creationId xmlns:a16="http://schemas.microsoft.com/office/drawing/2014/main" id="{3FFAA2D0-E045-DA01-6755-0697450E05A2}"/>
+              </a:ext>
+            </a:extLst>
+          </p:cNvPr>
+          <p:cNvSpPr/>
+          <p:nvPr/>
+        </p:nvSpPr>
+        <p:spPr>
+          <a:xfrm>
+            <a:off x="5496564" y="4467325"/>
+            <a:ext cx="4598793" cy="970737"/>
+          </a:xfrm>
+          <a:prstGeom prst="rect">
+            <a:avLst/>
+          </a:prstGeom>
+          <a:solidFill>
+            <a:schemeClr val="accent4">
+              <a:lumMod val="40000"/>
+              <a:lumOff val="60000"/>
+            </a:schemeClr>
+          </a:solidFill>
+        </p:spPr>
+        <p:style>
+          <a:lnRef idx="2">
+            <a:schemeClr val="accent1">
+              <a:shade val="50000"/>
+            </a:schemeClr>
+          </a:lnRef>
+          <a:fillRef idx="1">
+            <a:schemeClr val="accent1"/>
+          </a:fillRef>
+          <a:effectRef idx="0">
+            <a:schemeClr val="accent1"/>
+          </a:effectRef>
+          <a:fontRef idx="minor">
+            <a:schemeClr val="lt1"/>
+          </a:fontRef>
+        </p:style>
+        <p:txBody>
+          <a:bodyPr rtlCol="0" anchor="ctr"/>
+          <a:lstStyle/>
+          <a:p>
+            <a:pPr algn="ctr"/>
+            <a:r>
+              <a:rPr lang="en-IE" dirty="0">
+                <a:solidFill>
+                  <a:schemeClr val="tx1"/>
+                </a:solidFill>
+              </a:rPr>
+              <a:t>Add this to the abstract class</a:t>
+            </a:r>
+          </a:p>
+        </p:txBody>
+      </p:sp>
+      <p:cxnSp>
+        <p:nvCxnSpPr>
+          <p:cNvPr id="8" name="Straight Arrow Connector 7">
+            <a:extLst>
+              <a:ext uri="{FF2B5EF4-FFF2-40B4-BE49-F238E27FC236}">
+                <a16:creationId xmlns:a16="http://schemas.microsoft.com/office/drawing/2014/main" id="{F78D1E40-BBE5-EA01-A410-7D34A0284CA4}"/>
+              </a:ext>
+            </a:extLst>
+          </p:cNvPr>
+          <p:cNvCxnSpPr/>
+          <p:nvPr/>
+        </p:nvCxnSpPr>
+        <p:spPr>
+          <a:xfrm flipH="1">
+            <a:off x="4119613" y="5014762"/>
+            <a:ext cx="1232033" cy="0"/>
+          </a:xfrm>
+          <a:prstGeom prst="straightConnector1">
+            <a:avLst/>
+          </a:prstGeom>
+          <a:ln>
+            <a:tailEnd type="triangle"/>
+          </a:ln>
+        </p:spPr>
+        <p:style>
+          <a:lnRef idx="1">
+            <a:schemeClr val="accent1"/>
+          </a:lnRef>
+          <a:fillRef idx="0">
+            <a:schemeClr val="accent1"/>
+          </a:fillRef>
+          <a:effectRef idx="0">
+            <a:schemeClr val="accent1"/>
+          </a:effectRef>
+          <a:fontRef idx="minor">
+            <a:schemeClr val="tx1"/>
+          </a:fontRef>
+        </p:style>
+      </p:cxnSp>
+    </p:spTree>
+    <p:extLst>
+      <p:ext uri="{BB962C8B-B14F-4D97-AF65-F5344CB8AC3E}">
+        <p14:creationId xmlns:p14="http://schemas.microsoft.com/office/powerpoint/2010/main" val="2164239829"/>
+      </p:ext>
+    </p:extLst>
+  </p:cSld>
+  <p:clrMapOvr>
+    <a:masterClrMapping/>
+  </p:clrMapOvr>
+</p:sld>
+</file>
+
+<file path=ppt/slides/slide38.xml><?xml version="1.0" encoding="utf-8"?>
+<p:sld xmlns:a="http://schemas.openxmlformats.org/drawingml/2006/main" xmlns:r="http://schemas.openxmlformats.org/officeDocument/2006/relationships" xmlns:p="http://schemas.openxmlformats.org/presentationml/2006/main">
+  <p:cSld>
+    <p:spTree>
+      <p:nvGrpSpPr>
+        <p:cNvPr id="1" name=""/>
+        <p:cNvGrpSpPr/>
+        <p:nvPr/>
+      </p:nvGrpSpPr>
+      <p:grpSpPr>
+        <a:xfrm>
+          <a:off x="0" y="0"/>
+          <a:ext cx="0" cy="0"/>
+          <a:chOff x="0" y="0"/>
+          <a:chExt cx="0" cy="0"/>
+        </a:xfrm>
+      </p:grpSpPr>
+      <p:pic>
+        <p:nvPicPr>
+          <p:cNvPr id="5" name="Picture 4">
+            <a:extLst>
+              <a:ext uri="{FF2B5EF4-FFF2-40B4-BE49-F238E27FC236}">
+                <a16:creationId xmlns:a16="http://schemas.microsoft.com/office/drawing/2014/main" id="{BC87A773-B15B-C6B9-F10F-FECF22FDC71E}"/>
+              </a:ext>
+            </a:extLst>
+          </p:cNvPr>
+          <p:cNvPicPr>
+            <a:picLocks noChangeAspect="1"/>
+          </p:cNvPicPr>
+          <p:nvPr/>
+        </p:nvPicPr>
+        <p:blipFill>
+          <a:blip r:embed="rId2"/>
+          <a:stretch>
+            <a:fillRect/>
+          </a:stretch>
+        </p:blipFill>
+        <p:spPr>
+          <a:xfrm>
+            <a:off x="195713" y="2528354"/>
+            <a:ext cx="11800573" cy="1801292"/>
+          </a:xfrm>
+          <a:prstGeom prst="rect">
+            <a:avLst/>
+          </a:prstGeom>
+        </p:spPr>
+      </p:pic>
+      <p:sp>
+        <p:nvSpPr>
+          <p:cNvPr id="6" name="Rectangle 5">
+            <a:extLst>
+              <a:ext uri="{FF2B5EF4-FFF2-40B4-BE49-F238E27FC236}">
+                <a16:creationId xmlns:a16="http://schemas.microsoft.com/office/drawing/2014/main" id="{37E5071C-60CB-1C23-4ED8-7FF46721D6BF}"/>
+              </a:ext>
+            </a:extLst>
+          </p:cNvPr>
+          <p:cNvSpPr/>
+          <p:nvPr/>
+        </p:nvSpPr>
+        <p:spPr>
+          <a:xfrm>
+            <a:off x="597305" y="877102"/>
+            <a:ext cx="4598793" cy="970737"/>
+          </a:xfrm>
+          <a:prstGeom prst="rect">
+            <a:avLst/>
+          </a:prstGeom>
+          <a:solidFill>
+            <a:schemeClr val="accent4">
+              <a:lumMod val="40000"/>
+              <a:lumOff val="60000"/>
+            </a:schemeClr>
+          </a:solidFill>
+        </p:spPr>
+        <p:style>
+          <a:lnRef idx="2">
+            <a:schemeClr val="accent1">
+              <a:shade val="50000"/>
+            </a:schemeClr>
+          </a:lnRef>
+          <a:fillRef idx="1">
+            <a:schemeClr val="accent1"/>
+          </a:fillRef>
+          <a:effectRef idx="0">
+            <a:schemeClr val="accent1"/>
+          </a:effectRef>
+          <a:fontRef idx="minor">
+            <a:schemeClr val="lt1"/>
+          </a:fontRef>
+        </p:style>
+        <p:txBody>
+          <a:bodyPr rtlCol="0" anchor="ctr"/>
+          <a:lstStyle/>
+          <a:p>
+            <a:pPr algn="ctr"/>
+            <a:r>
+              <a:rPr lang="en-IE" dirty="0">
+                <a:solidFill>
+                  <a:schemeClr val="tx1"/>
+                </a:solidFill>
+              </a:rPr>
+              <a:t>Modify this to implement abstract method from base class</a:t>
+            </a:r>
+          </a:p>
+        </p:txBody>
+      </p:sp>
+      <p:sp>
+        <p:nvSpPr>
+          <p:cNvPr id="7" name="Rectangle 6">
+            <a:extLst>
+              <a:ext uri="{FF2B5EF4-FFF2-40B4-BE49-F238E27FC236}">
+                <a16:creationId xmlns:a16="http://schemas.microsoft.com/office/drawing/2014/main" id="{5F5991C2-C11A-1CFF-EA61-74152318C84C}"/>
+              </a:ext>
+            </a:extLst>
+          </p:cNvPr>
+          <p:cNvSpPr/>
+          <p:nvPr/>
+        </p:nvSpPr>
+        <p:spPr>
+          <a:xfrm>
+            <a:off x="1222411" y="2666198"/>
+            <a:ext cx="943276" cy="259882"/>
+          </a:xfrm>
+          <a:prstGeom prst="rect">
+            <a:avLst/>
+          </a:prstGeom>
+          <a:noFill/>
+        </p:spPr>
+        <p:style>
+          <a:lnRef idx="2">
+            <a:schemeClr val="accent1">
+              <a:shade val="15000"/>
+            </a:schemeClr>
+          </a:lnRef>
+          <a:fillRef idx="1">
+            <a:schemeClr val="accent1"/>
+          </a:fillRef>
+          <a:effectRef idx="0">
+            <a:schemeClr val="accent1"/>
+          </a:effectRef>
+          <a:fontRef idx="minor">
+            <a:schemeClr val="lt1"/>
+          </a:fontRef>
+        </p:style>
+        <p:txBody>
+          <a:bodyPr rtlCol="0" anchor="ctr"/>
+          <a:lstStyle/>
+          <a:p>
+            <a:pPr algn="ctr"/>
+            <a:endParaRPr lang="en-GB"/>
+          </a:p>
+        </p:txBody>
+      </p:sp>
+      <p:cxnSp>
+        <p:nvCxnSpPr>
+          <p:cNvPr id="9" name="Straight Arrow Connector 8">
+            <a:extLst>
+              <a:ext uri="{FF2B5EF4-FFF2-40B4-BE49-F238E27FC236}">
+                <a16:creationId xmlns:a16="http://schemas.microsoft.com/office/drawing/2014/main" id="{75DDC459-390A-9DD4-94C4-0CDEB03270BE}"/>
+              </a:ext>
+            </a:extLst>
+          </p:cNvPr>
+          <p:cNvCxnSpPr/>
+          <p:nvPr/>
+        </p:nvCxnSpPr>
+        <p:spPr>
+          <a:xfrm flipH="1">
+            <a:off x="1973179" y="1847839"/>
+            <a:ext cx="356135" cy="500725"/>
+          </a:xfrm>
+          <a:prstGeom prst="straightConnector1">
+            <a:avLst/>
+          </a:prstGeom>
+          <a:ln>
+            <a:tailEnd type="triangle"/>
+          </a:ln>
+        </p:spPr>
+        <p:style>
+          <a:lnRef idx="1">
+            <a:schemeClr val="accent1"/>
+          </a:lnRef>
+          <a:fillRef idx="0">
+            <a:schemeClr val="accent1"/>
+          </a:fillRef>
+          <a:effectRef idx="0">
+            <a:schemeClr val="accent1"/>
+          </a:effectRef>
+          <a:fontRef idx="minor">
+            <a:schemeClr val="tx1"/>
+          </a:fontRef>
+        </p:style>
+      </p:cxnSp>
+    </p:spTree>
+    <p:extLst>
+      <p:ext uri="{BB962C8B-B14F-4D97-AF65-F5344CB8AC3E}">
+        <p14:creationId xmlns:p14="http://schemas.microsoft.com/office/powerpoint/2010/main" val="4081973646"/>
+      </p:ext>
+    </p:extLst>
+  </p:cSld>
+  <p:clrMapOvr>
+    <a:masterClrMapping/>
+  </p:clrMapOvr>
+</p:sld>
+</file>
+
+<file path=ppt/slides/slide39.xml><?xml version="1.0" encoding="utf-8"?>
+<p:sld xmlns:a="http://schemas.openxmlformats.org/drawingml/2006/main" xmlns:r="http://schemas.openxmlformats.org/officeDocument/2006/relationships" xmlns:p="http://schemas.openxmlformats.org/presentationml/2006/main">
+  <p:cSld>
+    <p:spTree>
+      <p:nvGrpSpPr>
+        <p:cNvPr id="1" name=""/>
+        <p:cNvGrpSpPr/>
+        <p:nvPr/>
+      </p:nvGrpSpPr>
+      <p:grpSpPr>
+        <a:xfrm>
+          <a:off x="0" y="0"/>
+          <a:ext cx="0" cy="0"/>
+          <a:chOff x="0" y="0"/>
+          <a:chExt cx="0" cy="0"/>
+        </a:xfrm>
+      </p:grpSpPr>
+      <p:sp>
+        <p:nvSpPr>
+          <p:cNvPr id="2" name="Title 1">
+            <a:extLst>
+              <a:ext uri="{FF2B5EF4-FFF2-40B4-BE49-F238E27FC236}">
+                <a16:creationId xmlns:a16="http://schemas.microsoft.com/office/drawing/2014/main" id="{64F2D141-63A9-403A-8A02-0B31473E37A5}"/>
+              </a:ext>
+            </a:extLst>
+          </p:cNvPr>
+          <p:cNvSpPr>
+            <a:spLocks noGrp="1"/>
+          </p:cNvSpPr>
+          <p:nvPr>
+            <p:ph type="title"/>
+          </p:nvPr>
+        </p:nvSpPr>
+        <p:spPr/>
+        <p:txBody>
+          <a:bodyPr/>
+          <a:lstStyle/>
+          <a:p>
+            <a:endParaRPr lang="en-GB"/>
+          </a:p>
+        </p:txBody>
+      </p:sp>
+      <p:sp>
+        <p:nvSpPr>
+          <p:cNvPr id="3" name="Text Placeholder 2">
+            <a:extLst>
+              <a:ext uri="{FF2B5EF4-FFF2-40B4-BE49-F238E27FC236}">
+                <a16:creationId xmlns:a16="http://schemas.microsoft.com/office/drawing/2014/main" id="{D9DB5BD4-AEFA-F103-842A-3FEAD57A3D00}"/>
+              </a:ext>
+            </a:extLst>
+          </p:cNvPr>
+          <p:cNvSpPr>
+            <a:spLocks noGrp="1"/>
+          </p:cNvSpPr>
+          <p:nvPr>
+            <p:ph type="body" idx="1"/>
+          </p:nvPr>
+        </p:nvSpPr>
+        <p:spPr/>
+        <p:txBody>
+          <a:bodyPr/>
+          <a:lstStyle/>
+          <a:p>
+            <a:endParaRPr lang="en-GB"/>
+          </a:p>
+        </p:txBody>
+      </p:sp>
+    </p:spTree>
+    <p:extLst>
+      <p:ext uri="{BB962C8B-B14F-4D97-AF65-F5344CB8AC3E}">
+        <p14:creationId xmlns:p14="http://schemas.microsoft.com/office/powerpoint/2010/main" val="4142992940"/>
+      </p:ext>
+    </p:extLst>
+  </p:cSld>
+  <p:clrMapOvr>
+    <a:masterClrMapping/>
+  </p:clrMapOvr>
+</p:sld>
+</file>
+
 <file path=ppt/slides/slide4.xml><?xml version="1.0" encoding="utf-8"?>
 <p:sld xmlns:a="http://schemas.openxmlformats.org/drawingml/2006/main" xmlns:r="http://schemas.openxmlformats.org/officeDocument/2006/relationships" xmlns:p="http://schemas.openxmlformats.org/presentationml/2006/main">
   <p:cSld>
@@ -6272,6 +7202,326 @@
     <p:extLst>
       <p:ext uri="{BB962C8B-B14F-4D97-AF65-F5344CB8AC3E}">
         <p14:creationId xmlns:p14="http://schemas.microsoft.com/office/powerpoint/2010/main" val="488773756"/>
+      </p:ext>
+    </p:extLst>
+  </p:cSld>
+  <p:clrMapOvr>
+    <a:masterClrMapping/>
+  </p:clrMapOvr>
+</p:sld>
+</file>
+
+<file path=ppt/slides/slide40.xml><?xml version="1.0" encoding="utf-8"?>
+<p:sld xmlns:a="http://schemas.openxmlformats.org/drawingml/2006/main" xmlns:r="http://schemas.openxmlformats.org/officeDocument/2006/relationships" xmlns:p="http://schemas.openxmlformats.org/presentationml/2006/main">
+  <p:cSld>
+    <p:spTree>
+      <p:nvGrpSpPr>
+        <p:cNvPr id="1" name=""/>
+        <p:cNvGrpSpPr/>
+        <p:nvPr/>
+      </p:nvGrpSpPr>
+      <p:grpSpPr>
+        <a:xfrm>
+          <a:off x="0" y="0"/>
+          <a:ext cx="0" cy="0"/>
+          <a:chOff x="0" y="0"/>
+          <a:chExt cx="0" cy="0"/>
+        </a:xfrm>
+      </p:grpSpPr>
+      <p:sp>
+        <p:nvSpPr>
+          <p:cNvPr id="2" name="Title 1">
+            <a:extLst>
+              <a:ext uri="{FF2B5EF4-FFF2-40B4-BE49-F238E27FC236}">
+                <a16:creationId xmlns:a16="http://schemas.microsoft.com/office/drawing/2014/main" id="{4D2B38F2-DAFE-8B22-44EE-CAFFB081FE3B}"/>
+              </a:ext>
+            </a:extLst>
+          </p:cNvPr>
+          <p:cNvSpPr>
+            <a:spLocks noGrp="1"/>
+          </p:cNvSpPr>
+          <p:nvPr>
+            <p:ph type="title"/>
+          </p:nvPr>
+        </p:nvSpPr>
+        <p:spPr/>
+        <p:txBody>
+          <a:bodyPr/>
+          <a:lstStyle/>
+          <a:p>
+            <a:endParaRPr lang="en-GB"/>
+          </a:p>
+        </p:txBody>
+      </p:sp>
+      <p:sp>
+        <p:nvSpPr>
+          <p:cNvPr id="3" name="Text Placeholder 2">
+            <a:extLst>
+              <a:ext uri="{FF2B5EF4-FFF2-40B4-BE49-F238E27FC236}">
+                <a16:creationId xmlns:a16="http://schemas.microsoft.com/office/drawing/2014/main" id="{7BE27874-114B-03C6-C95A-507B42BA0758}"/>
+              </a:ext>
+            </a:extLst>
+          </p:cNvPr>
+          <p:cNvSpPr>
+            <a:spLocks noGrp="1"/>
+          </p:cNvSpPr>
+          <p:nvPr>
+            <p:ph type="body" idx="1"/>
+          </p:nvPr>
+        </p:nvSpPr>
+        <p:spPr/>
+        <p:txBody>
+          <a:bodyPr/>
+          <a:lstStyle/>
+          <a:p>
+            <a:endParaRPr lang="en-GB"/>
+          </a:p>
+        </p:txBody>
+      </p:sp>
+    </p:spTree>
+    <p:extLst>
+      <p:ext uri="{BB962C8B-B14F-4D97-AF65-F5344CB8AC3E}">
+        <p14:creationId xmlns:p14="http://schemas.microsoft.com/office/powerpoint/2010/main" val="2096573669"/>
+      </p:ext>
+    </p:extLst>
+  </p:cSld>
+  <p:clrMapOvr>
+    <a:masterClrMapping/>
+  </p:clrMapOvr>
+</p:sld>
+</file>
+
+<file path=ppt/slides/slide41.xml><?xml version="1.0" encoding="utf-8"?>
+<p:sld xmlns:a="http://schemas.openxmlformats.org/drawingml/2006/main" xmlns:r="http://schemas.openxmlformats.org/officeDocument/2006/relationships" xmlns:p="http://schemas.openxmlformats.org/presentationml/2006/main">
+  <p:cSld>
+    <p:spTree>
+      <p:nvGrpSpPr>
+        <p:cNvPr id="1" name=""/>
+        <p:cNvGrpSpPr/>
+        <p:nvPr/>
+      </p:nvGrpSpPr>
+      <p:grpSpPr>
+        <a:xfrm>
+          <a:off x="0" y="0"/>
+          <a:ext cx="0" cy="0"/>
+          <a:chOff x="0" y="0"/>
+          <a:chExt cx="0" cy="0"/>
+        </a:xfrm>
+      </p:grpSpPr>
+      <p:sp>
+        <p:nvSpPr>
+          <p:cNvPr id="2" name="Title 1">
+            <a:extLst>
+              <a:ext uri="{FF2B5EF4-FFF2-40B4-BE49-F238E27FC236}">
+                <a16:creationId xmlns:a16="http://schemas.microsoft.com/office/drawing/2014/main" id="{CDE48A65-0C4C-0A0B-AC33-AC4B5949C67F}"/>
+              </a:ext>
+            </a:extLst>
+          </p:cNvPr>
+          <p:cNvSpPr>
+            <a:spLocks noGrp="1"/>
+          </p:cNvSpPr>
+          <p:nvPr>
+            <p:ph type="title"/>
+          </p:nvPr>
+        </p:nvSpPr>
+        <p:spPr/>
+        <p:txBody>
+          <a:bodyPr/>
+          <a:lstStyle/>
+          <a:p>
+            <a:endParaRPr lang="en-GB"/>
+          </a:p>
+        </p:txBody>
+      </p:sp>
+      <p:sp>
+        <p:nvSpPr>
+          <p:cNvPr id="3" name="Text Placeholder 2">
+            <a:extLst>
+              <a:ext uri="{FF2B5EF4-FFF2-40B4-BE49-F238E27FC236}">
+                <a16:creationId xmlns:a16="http://schemas.microsoft.com/office/drawing/2014/main" id="{508E0947-8BE3-8F21-95C9-4413EB26348E}"/>
+              </a:ext>
+            </a:extLst>
+          </p:cNvPr>
+          <p:cNvSpPr>
+            <a:spLocks noGrp="1"/>
+          </p:cNvSpPr>
+          <p:nvPr>
+            <p:ph type="body" idx="1"/>
+          </p:nvPr>
+        </p:nvSpPr>
+        <p:spPr/>
+        <p:txBody>
+          <a:bodyPr/>
+          <a:lstStyle/>
+          <a:p>
+            <a:endParaRPr lang="en-GB"/>
+          </a:p>
+        </p:txBody>
+      </p:sp>
+    </p:spTree>
+    <p:extLst>
+      <p:ext uri="{BB962C8B-B14F-4D97-AF65-F5344CB8AC3E}">
+        <p14:creationId xmlns:p14="http://schemas.microsoft.com/office/powerpoint/2010/main" val="1955045216"/>
+      </p:ext>
+    </p:extLst>
+  </p:cSld>
+  <p:clrMapOvr>
+    <a:masterClrMapping/>
+  </p:clrMapOvr>
+</p:sld>
+</file>
+
+<file path=ppt/slides/slide42.xml><?xml version="1.0" encoding="utf-8"?>
+<p:sld xmlns:a="http://schemas.openxmlformats.org/drawingml/2006/main" xmlns:r="http://schemas.openxmlformats.org/officeDocument/2006/relationships" xmlns:p="http://schemas.openxmlformats.org/presentationml/2006/main">
+  <p:cSld>
+    <p:spTree>
+      <p:nvGrpSpPr>
+        <p:cNvPr id="1" name=""/>
+        <p:cNvGrpSpPr/>
+        <p:nvPr/>
+      </p:nvGrpSpPr>
+      <p:grpSpPr>
+        <a:xfrm>
+          <a:off x="0" y="0"/>
+          <a:ext cx="0" cy="0"/>
+          <a:chOff x="0" y="0"/>
+          <a:chExt cx="0" cy="0"/>
+        </a:xfrm>
+      </p:grpSpPr>
+      <p:sp>
+        <p:nvSpPr>
+          <p:cNvPr id="2" name="Title 1">
+            <a:extLst>
+              <a:ext uri="{FF2B5EF4-FFF2-40B4-BE49-F238E27FC236}">
+                <a16:creationId xmlns:a16="http://schemas.microsoft.com/office/drawing/2014/main" id="{DF180E21-FA5E-AB13-5518-193D6E56CA3D}"/>
+              </a:ext>
+            </a:extLst>
+          </p:cNvPr>
+          <p:cNvSpPr>
+            <a:spLocks noGrp="1"/>
+          </p:cNvSpPr>
+          <p:nvPr>
+            <p:ph type="title"/>
+          </p:nvPr>
+        </p:nvSpPr>
+        <p:spPr/>
+        <p:txBody>
+          <a:bodyPr/>
+          <a:lstStyle/>
+          <a:p>
+            <a:endParaRPr lang="en-GB"/>
+          </a:p>
+        </p:txBody>
+      </p:sp>
+      <p:sp>
+        <p:nvSpPr>
+          <p:cNvPr id="3" name="Text Placeholder 2">
+            <a:extLst>
+              <a:ext uri="{FF2B5EF4-FFF2-40B4-BE49-F238E27FC236}">
+                <a16:creationId xmlns:a16="http://schemas.microsoft.com/office/drawing/2014/main" id="{E5ADF57A-3FA8-B6FE-5EBB-B398E2D10466}"/>
+              </a:ext>
+            </a:extLst>
+          </p:cNvPr>
+          <p:cNvSpPr>
+            <a:spLocks noGrp="1"/>
+          </p:cNvSpPr>
+          <p:nvPr>
+            <p:ph type="body" idx="1"/>
+          </p:nvPr>
+        </p:nvSpPr>
+        <p:spPr/>
+        <p:txBody>
+          <a:bodyPr/>
+          <a:lstStyle/>
+          <a:p>
+            <a:endParaRPr lang="en-GB"/>
+          </a:p>
+        </p:txBody>
+      </p:sp>
+    </p:spTree>
+    <p:extLst>
+      <p:ext uri="{BB962C8B-B14F-4D97-AF65-F5344CB8AC3E}">
+        <p14:creationId xmlns:p14="http://schemas.microsoft.com/office/powerpoint/2010/main" val="73006775"/>
+      </p:ext>
+    </p:extLst>
+  </p:cSld>
+  <p:clrMapOvr>
+    <a:masterClrMapping/>
+  </p:clrMapOvr>
+</p:sld>
+</file>
+
+<file path=ppt/slides/slide43.xml><?xml version="1.0" encoding="utf-8"?>
+<p:sld xmlns:a="http://schemas.openxmlformats.org/drawingml/2006/main" xmlns:r="http://schemas.openxmlformats.org/officeDocument/2006/relationships" xmlns:p="http://schemas.openxmlformats.org/presentationml/2006/main">
+  <p:cSld>
+    <p:spTree>
+      <p:nvGrpSpPr>
+        <p:cNvPr id="1" name=""/>
+        <p:cNvGrpSpPr/>
+        <p:nvPr/>
+      </p:nvGrpSpPr>
+      <p:grpSpPr>
+        <a:xfrm>
+          <a:off x="0" y="0"/>
+          <a:ext cx="0" cy="0"/>
+          <a:chOff x="0" y="0"/>
+          <a:chExt cx="0" cy="0"/>
+        </a:xfrm>
+      </p:grpSpPr>
+      <p:sp>
+        <p:nvSpPr>
+          <p:cNvPr id="2" name="Title 1">
+            <a:extLst>
+              <a:ext uri="{FF2B5EF4-FFF2-40B4-BE49-F238E27FC236}">
+                <a16:creationId xmlns:a16="http://schemas.microsoft.com/office/drawing/2014/main" id="{88CABA1B-FB23-971D-1CB2-5225504941AB}"/>
+              </a:ext>
+            </a:extLst>
+          </p:cNvPr>
+          <p:cNvSpPr>
+            <a:spLocks noGrp="1"/>
+          </p:cNvSpPr>
+          <p:nvPr>
+            <p:ph type="title"/>
+          </p:nvPr>
+        </p:nvSpPr>
+        <p:spPr/>
+        <p:txBody>
+          <a:bodyPr/>
+          <a:lstStyle/>
+          <a:p>
+            <a:endParaRPr lang="en-GB"/>
+          </a:p>
+        </p:txBody>
+      </p:sp>
+      <p:sp>
+        <p:nvSpPr>
+          <p:cNvPr id="3" name="Text Placeholder 2">
+            <a:extLst>
+              <a:ext uri="{FF2B5EF4-FFF2-40B4-BE49-F238E27FC236}">
+                <a16:creationId xmlns:a16="http://schemas.microsoft.com/office/drawing/2014/main" id="{F51FC2B8-AD28-6B87-9822-7E7A55C488D2}"/>
+              </a:ext>
+            </a:extLst>
+          </p:cNvPr>
+          <p:cNvSpPr>
+            <a:spLocks noGrp="1"/>
+          </p:cNvSpPr>
+          <p:nvPr>
+            <p:ph type="body" idx="1"/>
+          </p:nvPr>
+        </p:nvSpPr>
+        <p:spPr/>
+        <p:txBody>
+          <a:bodyPr/>
+          <a:lstStyle/>
+          <a:p>
+            <a:endParaRPr lang="en-GB"/>
+          </a:p>
+        </p:txBody>
+      </p:sp>
+    </p:spTree>
+    <p:extLst>
+      <p:ext uri="{BB962C8B-B14F-4D97-AF65-F5344CB8AC3E}">
+        <p14:creationId xmlns:p14="http://schemas.microsoft.com/office/powerpoint/2010/main" val="3808289765"/>
       </p:ext>
     </p:extLst>
   </p:cSld>

</xml_diff>

<commit_message>
Add more interface methods
</commit_message>
<xml_diff>
--- a/CameraKit Walkthrough.pptx
+++ b/CameraKit Walkthrough.pptx
@@ -48,6 +48,14 @@
     <p:sldId id="296" r:id="rId42"/>
     <p:sldId id="297" r:id="rId43"/>
     <p:sldId id="298" r:id="rId44"/>
+    <p:sldId id="299" r:id="rId45"/>
+    <p:sldId id="300" r:id="rId46"/>
+    <p:sldId id="301" r:id="rId47"/>
+    <p:sldId id="302" r:id="rId48"/>
+    <p:sldId id="303" r:id="rId49"/>
+    <p:sldId id="304" r:id="rId50"/>
+    <p:sldId id="305" r:id="rId51"/>
+    <p:sldId id="306" r:id="rId52"/>
   </p:sldIdLst>
   <p:sldSz cx="12192000" cy="6858000"/>
   <p:notesSz cx="6858000" cy="9144000"/>
@@ -6695,6 +6703,108 @@
           </a:p>
         </p:txBody>
       </p:sp>
+      <p:cxnSp>
+        <p:nvCxnSpPr>
+          <p:cNvPr id="11" name="Straight Connector 10">
+            <a:extLst>
+              <a:ext uri="{FF2B5EF4-FFF2-40B4-BE49-F238E27FC236}">
+                <a16:creationId xmlns:a16="http://schemas.microsoft.com/office/drawing/2014/main" id="{F649D702-9337-98B7-1A4A-A8880FE0A019}"/>
+              </a:ext>
+            </a:extLst>
+          </p:cNvPr>
+          <p:cNvCxnSpPr/>
+          <p:nvPr/>
+        </p:nvCxnSpPr>
+        <p:spPr>
+          <a:xfrm>
+            <a:off x="1155032" y="3936733"/>
+            <a:ext cx="1309035" cy="1039528"/>
+          </a:xfrm>
+          <a:prstGeom prst="line">
+            <a:avLst/>
+          </a:prstGeom>
+        </p:spPr>
+        <p:style>
+          <a:lnRef idx="1">
+            <a:schemeClr val="accent1"/>
+          </a:lnRef>
+          <a:fillRef idx="0">
+            <a:schemeClr val="accent1"/>
+          </a:fillRef>
+          <a:effectRef idx="0">
+            <a:schemeClr val="accent1"/>
+          </a:effectRef>
+          <a:fontRef idx="minor">
+            <a:schemeClr val="tx1"/>
+          </a:fontRef>
+        </p:style>
+      </p:cxnSp>
+      <p:cxnSp>
+        <p:nvCxnSpPr>
+          <p:cNvPr id="13" name="Straight Connector 12">
+            <a:extLst>
+              <a:ext uri="{FF2B5EF4-FFF2-40B4-BE49-F238E27FC236}">
+                <a16:creationId xmlns:a16="http://schemas.microsoft.com/office/drawing/2014/main" id="{2ABDEB68-668A-2818-C2D7-29410C7BD490}"/>
+              </a:ext>
+            </a:extLst>
+          </p:cNvPr>
+          <p:cNvCxnSpPr/>
+          <p:nvPr/>
+        </p:nvCxnSpPr>
+        <p:spPr>
+          <a:xfrm flipH="1">
+            <a:off x="1318661" y="3917482"/>
+            <a:ext cx="1251284" cy="1029903"/>
+          </a:xfrm>
+          <a:prstGeom prst="line">
+            <a:avLst/>
+          </a:prstGeom>
+        </p:spPr>
+        <p:style>
+          <a:lnRef idx="1">
+            <a:schemeClr val="accent1"/>
+          </a:lnRef>
+          <a:fillRef idx="0">
+            <a:schemeClr val="accent1"/>
+          </a:fillRef>
+          <a:effectRef idx="0">
+            <a:schemeClr val="accent1"/>
+          </a:effectRef>
+          <a:fontRef idx="minor">
+            <a:schemeClr val="tx1"/>
+          </a:fontRef>
+        </p:style>
+      </p:cxnSp>
+      <p:pic>
+        <p:nvPicPr>
+          <p:cNvPr id="15" name="Picture 14">
+            <a:extLst>
+              <a:ext uri="{FF2B5EF4-FFF2-40B4-BE49-F238E27FC236}">
+                <a16:creationId xmlns:a16="http://schemas.microsoft.com/office/drawing/2014/main" id="{9758352B-379C-3492-D74D-118ECBCC6F72}"/>
+              </a:ext>
+            </a:extLst>
+          </p:cNvPr>
+          <p:cNvPicPr>
+            <a:picLocks noChangeAspect="1"/>
+          </p:cNvPicPr>
+          <p:nvPr/>
+        </p:nvPicPr>
+        <p:blipFill>
+          <a:blip r:embed="rId3"/>
+          <a:stretch>
+            <a:fillRect/>
+          </a:stretch>
+        </p:blipFill>
+        <p:spPr>
+          <a:xfrm>
+            <a:off x="919181" y="5255393"/>
+            <a:ext cx="10000228" cy="1330609"/>
+          </a:xfrm>
+          <a:prstGeom prst="rect">
+            <a:avLst/>
+          </a:prstGeom>
+        </p:spPr>
+      </p:pic>
     </p:spTree>
     <p:extLst>
       <p:ext uri="{BB962C8B-B14F-4D97-AF65-F5344CB8AC3E}">
@@ -7088,56 +7198,105 @@
           <a:chExt cx="0" cy="0"/>
         </a:xfrm>
       </p:grpSpPr>
-      <p:sp>
-        <p:nvSpPr>
-          <p:cNvPr id="2" name="Title 1">
-            <a:extLst>
-              <a:ext uri="{FF2B5EF4-FFF2-40B4-BE49-F238E27FC236}">
-                <a16:creationId xmlns:a16="http://schemas.microsoft.com/office/drawing/2014/main" id="{64F2D141-63A9-403A-8A02-0B31473E37A5}"/>
-              </a:ext>
-            </a:extLst>
-          </p:cNvPr>
-          <p:cNvSpPr>
-            <a:spLocks noGrp="1"/>
-          </p:cNvSpPr>
-          <p:nvPr>
-            <p:ph type="title"/>
-          </p:nvPr>
-        </p:nvSpPr>
-        <p:spPr/>
-        <p:txBody>
-          <a:bodyPr/>
-          <a:lstStyle/>
-          <a:p>
-            <a:endParaRPr lang="en-GB"/>
-          </a:p>
-        </p:txBody>
-      </p:sp>
-      <p:sp>
-        <p:nvSpPr>
-          <p:cNvPr id="3" name="Text Placeholder 2">
-            <a:extLst>
-              <a:ext uri="{FF2B5EF4-FFF2-40B4-BE49-F238E27FC236}">
-                <a16:creationId xmlns:a16="http://schemas.microsoft.com/office/drawing/2014/main" id="{D9DB5BD4-AEFA-F103-842A-3FEAD57A3D00}"/>
-              </a:ext>
-            </a:extLst>
-          </p:cNvPr>
-          <p:cNvSpPr>
-            <a:spLocks noGrp="1"/>
-          </p:cNvSpPr>
-          <p:nvPr>
-            <p:ph type="body" idx="1"/>
-          </p:nvPr>
-        </p:nvSpPr>
-        <p:spPr/>
-        <p:txBody>
-          <a:bodyPr/>
-          <a:lstStyle/>
-          <a:p>
-            <a:endParaRPr lang="en-GB"/>
-          </a:p>
-        </p:txBody>
-      </p:sp>
+      <p:pic>
+        <p:nvPicPr>
+          <p:cNvPr id="7" name="Picture 6">
+            <a:extLst>
+              <a:ext uri="{FF2B5EF4-FFF2-40B4-BE49-F238E27FC236}">
+                <a16:creationId xmlns:a16="http://schemas.microsoft.com/office/drawing/2014/main" id="{1997F211-3BBA-8C38-8964-235CE5B1473B}"/>
+              </a:ext>
+            </a:extLst>
+          </p:cNvPr>
+          <p:cNvPicPr>
+            <a:picLocks noChangeAspect="1"/>
+          </p:cNvPicPr>
+          <p:nvPr/>
+        </p:nvPicPr>
+        <p:blipFill>
+          <a:blip r:embed="rId2"/>
+          <a:stretch>
+            <a:fillRect/>
+          </a:stretch>
+        </p:blipFill>
+        <p:spPr>
+          <a:xfrm>
+            <a:off x="2788682" y="245579"/>
+            <a:ext cx="5492670" cy="2218487"/>
+          </a:xfrm>
+          <a:prstGeom prst="rect">
+            <a:avLst/>
+          </a:prstGeom>
+        </p:spPr>
+      </p:pic>
+      <p:pic>
+        <p:nvPicPr>
+          <p:cNvPr id="9" name="Picture 8">
+            <a:extLst>
+              <a:ext uri="{FF2B5EF4-FFF2-40B4-BE49-F238E27FC236}">
+                <a16:creationId xmlns:a16="http://schemas.microsoft.com/office/drawing/2014/main" id="{180957E3-89DC-CFDF-3344-0D3E9771B5B0}"/>
+              </a:ext>
+            </a:extLst>
+          </p:cNvPr>
+          <p:cNvPicPr>
+            <a:picLocks noChangeAspect="1"/>
+          </p:cNvPicPr>
+          <p:nvPr/>
+        </p:nvPicPr>
+        <p:blipFill>
+          <a:blip r:embed="rId3"/>
+          <a:stretch>
+            <a:fillRect/>
+          </a:stretch>
+        </p:blipFill>
+        <p:spPr>
+          <a:xfrm>
+            <a:off x="683211" y="4117466"/>
+            <a:ext cx="11271367" cy="1474812"/>
+          </a:xfrm>
+          <a:prstGeom prst="rect">
+            <a:avLst/>
+          </a:prstGeom>
+        </p:spPr>
+      </p:pic>
+      <p:cxnSp>
+        <p:nvCxnSpPr>
+          <p:cNvPr id="11" name="Straight Arrow Connector 10">
+            <a:extLst>
+              <a:ext uri="{FF2B5EF4-FFF2-40B4-BE49-F238E27FC236}">
+                <a16:creationId xmlns:a16="http://schemas.microsoft.com/office/drawing/2014/main" id="{CEDED1B5-2B17-6F7B-829D-44E013B001C4}"/>
+              </a:ext>
+            </a:extLst>
+          </p:cNvPr>
+          <p:cNvCxnSpPr/>
+          <p:nvPr/>
+        </p:nvCxnSpPr>
+        <p:spPr>
+          <a:xfrm flipH="1">
+            <a:off x="8412480" y="2645873"/>
+            <a:ext cx="644892" cy="1289786"/>
+          </a:xfrm>
+          <a:prstGeom prst="straightConnector1">
+            <a:avLst/>
+          </a:prstGeom>
+          <a:ln>
+            <a:tailEnd type="triangle"/>
+          </a:ln>
+        </p:spPr>
+        <p:style>
+          <a:lnRef idx="1">
+            <a:schemeClr val="accent1"/>
+          </a:lnRef>
+          <a:fillRef idx="0">
+            <a:schemeClr val="accent1"/>
+          </a:fillRef>
+          <a:effectRef idx="0">
+            <a:schemeClr val="accent1"/>
+          </a:effectRef>
+          <a:fontRef idx="minor">
+            <a:schemeClr val="tx1"/>
+          </a:fontRef>
+        </p:style>
+      </p:cxnSp>
     </p:spTree>
     <p:extLst>
       <p:ext uri="{BB962C8B-B14F-4D97-AF65-F5344CB8AC3E}">
@@ -7228,56 +7387,66 @@
           <a:chExt cx="0" cy="0"/>
         </a:xfrm>
       </p:grpSpPr>
-      <p:sp>
-        <p:nvSpPr>
-          <p:cNvPr id="2" name="Title 1">
-            <a:extLst>
-              <a:ext uri="{FF2B5EF4-FFF2-40B4-BE49-F238E27FC236}">
-                <a16:creationId xmlns:a16="http://schemas.microsoft.com/office/drawing/2014/main" id="{4D2B38F2-DAFE-8B22-44EE-CAFFB081FE3B}"/>
-              </a:ext>
-            </a:extLst>
-          </p:cNvPr>
-          <p:cNvSpPr>
-            <a:spLocks noGrp="1"/>
-          </p:cNvSpPr>
-          <p:nvPr>
-            <p:ph type="title"/>
-          </p:nvPr>
-        </p:nvSpPr>
-        <p:spPr/>
-        <p:txBody>
-          <a:bodyPr/>
-          <a:lstStyle/>
-          <a:p>
-            <a:endParaRPr lang="en-GB"/>
-          </a:p>
-        </p:txBody>
-      </p:sp>
-      <p:sp>
-        <p:nvSpPr>
-          <p:cNvPr id="3" name="Text Placeholder 2">
-            <a:extLst>
-              <a:ext uri="{FF2B5EF4-FFF2-40B4-BE49-F238E27FC236}">
-                <a16:creationId xmlns:a16="http://schemas.microsoft.com/office/drawing/2014/main" id="{7BE27874-114B-03C6-C95A-507B42BA0758}"/>
-              </a:ext>
-            </a:extLst>
-          </p:cNvPr>
-          <p:cNvSpPr>
-            <a:spLocks noGrp="1"/>
-          </p:cNvSpPr>
-          <p:nvPr>
-            <p:ph type="body" idx="1"/>
-          </p:nvPr>
-        </p:nvSpPr>
-        <p:spPr/>
-        <p:txBody>
-          <a:bodyPr/>
-          <a:lstStyle/>
-          <a:p>
-            <a:endParaRPr lang="en-GB"/>
-          </a:p>
-        </p:txBody>
-      </p:sp>
+      <p:pic>
+        <p:nvPicPr>
+          <p:cNvPr id="5" name="Picture 4">
+            <a:extLst>
+              <a:ext uri="{FF2B5EF4-FFF2-40B4-BE49-F238E27FC236}">
+                <a16:creationId xmlns:a16="http://schemas.microsoft.com/office/drawing/2014/main" id="{481F9B75-EC1C-AF42-3906-1901803A60FE}"/>
+              </a:ext>
+            </a:extLst>
+          </p:cNvPr>
+          <p:cNvPicPr>
+            <a:picLocks noChangeAspect="1"/>
+          </p:cNvPicPr>
+          <p:nvPr/>
+        </p:nvPicPr>
+        <p:blipFill>
+          <a:blip r:embed="rId2"/>
+          <a:stretch>
+            <a:fillRect/>
+          </a:stretch>
+        </p:blipFill>
+        <p:spPr>
+          <a:xfrm>
+            <a:off x="1955646" y="443463"/>
+            <a:ext cx="7746619" cy="4369441"/>
+          </a:xfrm>
+          <a:prstGeom prst="rect">
+            <a:avLst/>
+          </a:prstGeom>
+        </p:spPr>
+      </p:pic>
+      <p:pic>
+        <p:nvPicPr>
+          <p:cNvPr id="6" name="Picture 5">
+            <a:extLst>
+              <a:ext uri="{FF2B5EF4-FFF2-40B4-BE49-F238E27FC236}">
+                <a16:creationId xmlns:a16="http://schemas.microsoft.com/office/drawing/2014/main" id="{304B81AC-8435-34BE-CC4E-BC52762723C9}"/>
+              </a:ext>
+            </a:extLst>
+          </p:cNvPr>
+          <p:cNvPicPr>
+            <a:picLocks noChangeAspect="1"/>
+          </p:cNvPicPr>
+          <p:nvPr/>
+        </p:nvPicPr>
+        <p:blipFill>
+          <a:blip r:embed="rId3"/>
+          <a:stretch>
+            <a:fillRect/>
+          </a:stretch>
+        </p:blipFill>
+        <p:spPr>
+          <a:xfrm>
+            <a:off x="460316" y="5070367"/>
+            <a:ext cx="11271367" cy="1474812"/>
+          </a:xfrm>
+          <a:prstGeom prst="rect">
+            <a:avLst/>
+          </a:prstGeom>
+        </p:spPr>
+      </p:pic>
     </p:spTree>
     <p:extLst>
       <p:ext uri="{BB962C8B-B14F-4D97-AF65-F5344CB8AC3E}">
@@ -7308,53 +7477,325 @@
           <a:chExt cx="0" cy="0"/>
         </a:xfrm>
       </p:grpSpPr>
+      <p:pic>
+        <p:nvPicPr>
+          <p:cNvPr id="5" name="Picture 4">
+            <a:extLst>
+              <a:ext uri="{FF2B5EF4-FFF2-40B4-BE49-F238E27FC236}">
+                <a16:creationId xmlns:a16="http://schemas.microsoft.com/office/drawing/2014/main" id="{F730E9BC-3139-7AE8-8C1C-B46C88859466}"/>
+              </a:ext>
+            </a:extLst>
+          </p:cNvPr>
+          <p:cNvPicPr>
+            <a:picLocks noChangeAspect="1"/>
+          </p:cNvPicPr>
+          <p:nvPr/>
+        </p:nvPicPr>
+        <p:blipFill>
+          <a:blip r:embed="rId2"/>
+          <a:stretch>
+            <a:fillRect/>
+          </a:stretch>
+        </p:blipFill>
+        <p:spPr>
+          <a:xfrm>
+            <a:off x="796260" y="423908"/>
+            <a:ext cx="4323809" cy="2333333"/>
+          </a:xfrm>
+          <a:prstGeom prst="rect">
+            <a:avLst/>
+          </a:prstGeom>
+        </p:spPr>
+      </p:pic>
+      <p:pic>
+        <p:nvPicPr>
+          <p:cNvPr id="7" name="Picture 6">
+            <a:extLst>
+              <a:ext uri="{FF2B5EF4-FFF2-40B4-BE49-F238E27FC236}">
+                <a16:creationId xmlns:a16="http://schemas.microsoft.com/office/drawing/2014/main" id="{3FFD7A3A-B6D6-3B43-D09C-DAB512C2BB7A}"/>
+              </a:ext>
+            </a:extLst>
+          </p:cNvPr>
+          <p:cNvPicPr>
+            <a:picLocks noChangeAspect="1"/>
+          </p:cNvPicPr>
+          <p:nvPr/>
+        </p:nvPicPr>
+        <p:blipFill>
+          <a:blip r:embed="rId3"/>
+          <a:stretch>
+            <a:fillRect/>
+          </a:stretch>
+        </p:blipFill>
+        <p:spPr>
+          <a:xfrm>
+            <a:off x="962526" y="2847631"/>
+            <a:ext cx="8997895" cy="3372060"/>
+          </a:xfrm>
+          <a:prstGeom prst="rect">
+            <a:avLst/>
+          </a:prstGeom>
+        </p:spPr>
+      </p:pic>
       <p:sp>
         <p:nvSpPr>
-          <p:cNvPr id="2" name="Title 1">
-            <a:extLst>
-              <a:ext uri="{FF2B5EF4-FFF2-40B4-BE49-F238E27FC236}">
-                <a16:creationId xmlns:a16="http://schemas.microsoft.com/office/drawing/2014/main" id="{CDE48A65-0C4C-0A0B-AC33-AC4B5949C67F}"/>
-              </a:ext>
-            </a:extLst>
-          </p:cNvPr>
-          <p:cNvSpPr>
-            <a:spLocks noGrp="1"/>
-          </p:cNvSpPr>
-          <p:nvPr>
-            <p:ph type="title"/>
-          </p:nvPr>
+          <p:cNvPr id="8" name="Rectangle 7">
+            <a:extLst>
+              <a:ext uri="{FF2B5EF4-FFF2-40B4-BE49-F238E27FC236}">
+                <a16:creationId xmlns:a16="http://schemas.microsoft.com/office/drawing/2014/main" id="{90F462E6-A66D-9574-CD2C-9D4E65D2B39D}"/>
+              </a:ext>
+            </a:extLst>
+          </p:cNvPr>
+          <p:cNvSpPr/>
+          <p:nvPr/>
         </p:nvSpPr>
-        <p:spPr/>
+        <p:spPr>
+          <a:xfrm>
+            <a:off x="1318660" y="952901"/>
+            <a:ext cx="644893" cy="375385"/>
+          </a:xfrm>
+          <a:prstGeom prst="rect">
+            <a:avLst/>
+          </a:prstGeom>
+          <a:noFill/>
+        </p:spPr>
+        <p:style>
+          <a:lnRef idx="2">
+            <a:schemeClr val="accent1">
+              <a:shade val="15000"/>
+            </a:schemeClr>
+          </a:lnRef>
+          <a:fillRef idx="1">
+            <a:schemeClr val="accent1"/>
+          </a:fillRef>
+          <a:effectRef idx="0">
+            <a:schemeClr val="accent1"/>
+          </a:effectRef>
+          <a:fontRef idx="minor">
+            <a:schemeClr val="lt1"/>
+          </a:fontRef>
+        </p:style>
         <p:txBody>
-          <a:bodyPr/>
+          <a:bodyPr rtlCol="0" anchor="ctr"/>
           <a:lstStyle/>
           <a:p>
+            <a:pPr algn="ctr"/>
             <a:endParaRPr lang="en-GB"/>
           </a:p>
         </p:txBody>
       </p:sp>
+      <p:cxnSp>
+        <p:nvCxnSpPr>
+          <p:cNvPr id="10" name="Straight Arrow Connector 9">
+            <a:extLst>
+              <a:ext uri="{FF2B5EF4-FFF2-40B4-BE49-F238E27FC236}">
+                <a16:creationId xmlns:a16="http://schemas.microsoft.com/office/drawing/2014/main" id="{4EA0FF7A-1DBD-6691-861B-33CB0EC0F7BE}"/>
+              </a:ext>
+            </a:extLst>
+          </p:cNvPr>
+          <p:cNvCxnSpPr/>
+          <p:nvPr/>
+        </p:nvCxnSpPr>
+        <p:spPr>
+          <a:xfrm flipH="1">
+            <a:off x="2088682" y="77002"/>
+            <a:ext cx="1780674" cy="798897"/>
+          </a:xfrm>
+          <a:prstGeom prst="straightConnector1">
+            <a:avLst/>
+          </a:prstGeom>
+          <a:ln>
+            <a:tailEnd type="triangle"/>
+          </a:ln>
+        </p:spPr>
+        <p:style>
+          <a:lnRef idx="1">
+            <a:schemeClr val="accent1"/>
+          </a:lnRef>
+          <a:fillRef idx="0">
+            <a:schemeClr val="accent1"/>
+          </a:fillRef>
+          <a:effectRef idx="0">
+            <a:schemeClr val="accent1"/>
+          </a:effectRef>
+          <a:fontRef idx="minor">
+            <a:schemeClr val="tx1"/>
+          </a:fontRef>
+        </p:style>
+      </p:cxnSp>
+      <p:cxnSp>
+        <p:nvCxnSpPr>
+          <p:cNvPr id="11" name="Straight Arrow Connector 10">
+            <a:extLst>
+              <a:ext uri="{FF2B5EF4-FFF2-40B4-BE49-F238E27FC236}">
+                <a16:creationId xmlns:a16="http://schemas.microsoft.com/office/drawing/2014/main" id="{A09FD424-57F3-4DD8-C9C6-FE7DF8C992C8}"/>
+              </a:ext>
+            </a:extLst>
+          </p:cNvPr>
+          <p:cNvCxnSpPr/>
+          <p:nvPr/>
+        </p:nvCxnSpPr>
+        <p:spPr>
+          <a:xfrm flipH="1">
+            <a:off x="3415364" y="3429000"/>
+            <a:ext cx="1780674" cy="798897"/>
+          </a:xfrm>
+          <a:prstGeom prst="straightConnector1">
+            <a:avLst/>
+          </a:prstGeom>
+          <a:ln>
+            <a:tailEnd type="triangle"/>
+          </a:ln>
+        </p:spPr>
+        <p:style>
+          <a:lnRef idx="1">
+            <a:schemeClr val="accent1"/>
+          </a:lnRef>
+          <a:fillRef idx="0">
+            <a:schemeClr val="accent1"/>
+          </a:fillRef>
+          <a:effectRef idx="0">
+            <a:schemeClr val="accent1"/>
+          </a:effectRef>
+          <a:fontRef idx="minor">
+            <a:schemeClr val="tx1"/>
+          </a:fontRef>
+        </p:style>
+      </p:cxnSp>
+      <p:cxnSp>
+        <p:nvCxnSpPr>
+          <p:cNvPr id="12" name="Straight Arrow Connector 11">
+            <a:extLst>
+              <a:ext uri="{FF2B5EF4-FFF2-40B4-BE49-F238E27FC236}">
+                <a16:creationId xmlns:a16="http://schemas.microsoft.com/office/drawing/2014/main" id="{158C3CDB-C391-65EC-46FA-1BF246D35C69}"/>
+              </a:ext>
+            </a:extLst>
+          </p:cNvPr>
+          <p:cNvCxnSpPr/>
+          <p:nvPr/>
+        </p:nvCxnSpPr>
+        <p:spPr>
+          <a:xfrm flipH="1">
+            <a:off x="3548513" y="4533661"/>
+            <a:ext cx="1780674" cy="798897"/>
+          </a:xfrm>
+          <a:prstGeom prst="straightConnector1">
+            <a:avLst/>
+          </a:prstGeom>
+          <a:ln>
+            <a:tailEnd type="triangle"/>
+          </a:ln>
+        </p:spPr>
+        <p:style>
+          <a:lnRef idx="1">
+            <a:schemeClr val="accent1"/>
+          </a:lnRef>
+          <a:fillRef idx="0">
+            <a:schemeClr val="accent1"/>
+          </a:fillRef>
+          <a:effectRef idx="0">
+            <a:schemeClr val="accent1"/>
+          </a:effectRef>
+          <a:fontRef idx="minor">
+            <a:schemeClr val="tx1"/>
+          </a:fontRef>
+        </p:style>
+      </p:cxnSp>
+      <p:cxnSp>
+        <p:nvCxnSpPr>
+          <p:cNvPr id="13" name="Straight Arrow Connector 12">
+            <a:extLst>
+              <a:ext uri="{FF2B5EF4-FFF2-40B4-BE49-F238E27FC236}">
+                <a16:creationId xmlns:a16="http://schemas.microsoft.com/office/drawing/2014/main" id="{EA0EA304-62F3-12F4-CA34-F2CB77C451D4}"/>
+              </a:ext>
+            </a:extLst>
+          </p:cNvPr>
+          <p:cNvCxnSpPr/>
+          <p:nvPr/>
+        </p:nvCxnSpPr>
+        <p:spPr>
+          <a:xfrm flipH="1">
+            <a:off x="2231579" y="2003539"/>
+            <a:ext cx="1780674" cy="798897"/>
+          </a:xfrm>
+          <a:prstGeom prst="straightConnector1">
+            <a:avLst/>
+          </a:prstGeom>
+          <a:ln>
+            <a:tailEnd type="triangle"/>
+          </a:ln>
+        </p:spPr>
+        <p:style>
+          <a:lnRef idx="1">
+            <a:schemeClr val="accent1"/>
+          </a:lnRef>
+          <a:fillRef idx="0">
+            <a:schemeClr val="accent1"/>
+          </a:fillRef>
+          <a:effectRef idx="0">
+            <a:schemeClr val="accent1"/>
+          </a:effectRef>
+          <a:fontRef idx="minor">
+            <a:schemeClr val="tx1"/>
+          </a:fontRef>
+        </p:style>
+      </p:cxnSp>
       <p:sp>
         <p:nvSpPr>
-          <p:cNvPr id="3" name="Text Placeholder 2">
-            <a:extLst>
-              <a:ext uri="{FF2B5EF4-FFF2-40B4-BE49-F238E27FC236}">
-                <a16:creationId xmlns:a16="http://schemas.microsoft.com/office/drawing/2014/main" id="{508E0947-8BE3-8F21-95C9-4413EB26348E}"/>
-              </a:ext>
-            </a:extLst>
-          </p:cNvPr>
-          <p:cNvSpPr>
-            <a:spLocks noGrp="1"/>
-          </p:cNvSpPr>
-          <p:nvPr>
-            <p:ph type="body" idx="1"/>
-          </p:nvPr>
+          <p:cNvPr id="16" name="Rectangle 15">
+            <a:extLst>
+              <a:ext uri="{FF2B5EF4-FFF2-40B4-BE49-F238E27FC236}">
+                <a16:creationId xmlns:a16="http://schemas.microsoft.com/office/drawing/2014/main" id="{8D564A3A-CAFB-50BE-388F-EB52B00F8D25}"/>
+              </a:ext>
+            </a:extLst>
+          </p:cNvPr>
+          <p:cNvSpPr/>
+          <p:nvPr/>
         </p:nvSpPr>
-        <p:spPr/>
+        <p:spPr>
+          <a:xfrm>
+            <a:off x="6274547" y="1223612"/>
+            <a:ext cx="4598793" cy="970737"/>
+          </a:xfrm>
+          <a:prstGeom prst="rect">
+            <a:avLst/>
+          </a:prstGeom>
+          <a:solidFill>
+            <a:schemeClr val="accent4">
+              <a:lumMod val="40000"/>
+              <a:lumOff val="60000"/>
+            </a:schemeClr>
+          </a:solidFill>
+        </p:spPr>
+        <p:style>
+          <a:lnRef idx="2">
+            <a:schemeClr val="accent1">
+              <a:shade val="50000"/>
+            </a:schemeClr>
+          </a:lnRef>
+          <a:fillRef idx="1">
+            <a:schemeClr val="accent1"/>
+          </a:fillRef>
+          <a:effectRef idx="0">
+            <a:schemeClr val="accent1"/>
+          </a:effectRef>
+          <a:fontRef idx="minor">
+            <a:schemeClr val="lt1"/>
+          </a:fontRef>
+        </p:style>
         <p:txBody>
-          <a:bodyPr/>
+          <a:bodyPr rtlCol="0" anchor="ctr"/>
           <a:lstStyle/>
           <a:p>
-            <a:endParaRPr lang="en-GB"/>
+            <a:pPr algn="ctr"/>
+            <a:r>
+              <a:rPr lang="en-IE" dirty="0">
+                <a:solidFill>
+                  <a:schemeClr val="tx1"/>
+                </a:solidFill>
+              </a:rPr>
+              <a:t>Modify Book to return a bool (true/false) and update the method with return declaration and return values</a:t>
+            </a:r>
           </a:p>
         </p:txBody>
       </p:sp>
@@ -7388,56 +7829,177 @@
           <a:chExt cx="0" cy="0"/>
         </a:xfrm>
       </p:grpSpPr>
+      <p:pic>
+        <p:nvPicPr>
+          <p:cNvPr id="5" name="Picture 4">
+            <a:extLst>
+              <a:ext uri="{FF2B5EF4-FFF2-40B4-BE49-F238E27FC236}">
+                <a16:creationId xmlns:a16="http://schemas.microsoft.com/office/drawing/2014/main" id="{9F1AA596-877A-C1F9-4CE9-006B4E94260D}"/>
+              </a:ext>
+            </a:extLst>
+          </p:cNvPr>
+          <p:cNvPicPr>
+            <a:picLocks noChangeAspect="1"/>
+          </p:cNvPicPr>
+          <p:nvPr/>
+        </p:nvPicPr>
+        <p:blipFill>
+          <a:blip r:embed="rId2"/>
+          <a:stretch>
+            <a:fillRect/>
+          </a:stretch>
+        </p:blipFill>
+        <p:spPr>
+          <a:xfrm>
+            <a:off x="483603" y="1325346"/>
+            <a:ext cx="7784498" cy="4439691"/>
+          </a:xfrm>
+          <a:prstGeom prst="rect">
+            <a:avLst/>
+          </a:prstGeom>
+        </p:spPr>
+      </p:pic>
       <p:sp>
         <p:nvSpPr>
-          <p:cNvPr id="2" name="Title 1">
-            <a:extLst>
-              <a:ext uri="{FF2B5EF4-FFF2-40B4-BE49-F238E27FC236}">
-                <a16:creationId xmlns:a16="http://schemas.microsoft.com/office/drawing/2014/main" id="{DF180E21-FA5E-AB13-5518-193D6E56CA3D}"/>
-              </a:ext>
-            </a:extLst>
-          </p:cNvPr>
-          <p:cNvSpPr>
-            <a:spLocks noGrp="1"/>
-          </p:cNvSpPr>
-          <p:nvPr>
-            <p:ph type="title"/>
-          </p:nvPr>
+          <p:cNvPr id="10" name="Rectangle 9">
+            <a:extLst>
+              <a:ext uri="{FF2B5EF4-FFF2-40B4-BE49-F238E27FC236}">
+                <a16:creationId xmlns:a16="http://schemas.microsoft.com/office/drawing/2014/main" id="{F476451C-AC8C-7356-C9CD-AD3B39171AB8}"/>
+              </a:ext>
+            </a:extLst>
+          </p:cNvPr>
+          <p:cNvSpPr/>
+          <p:nvPr/>
         </p:nvSpPr>
-        <p:spPr/>
+        <p:spPr>
+          <a:xfrm>
+            <a:off x="7361465" y="4024563"/>
+            <a:ext cx="4598793" cy="970737"/>
+          </a:xfrm>
+          <a:prstGeom prst="rect">
+            <a:avLst/>
+          </a:prstGeom>
+          <a:solidFill>
+            <a:schemeClr val="accent4">
+              <a:lumMod val="40000"/>
+              <a:lumOff val="60000"/>
+            </a:schemeClr>
+          </a:solidFill>
+        </p:spPr>
+        <p:style>
+          <a:lnRef idx="2">
+            <a:schemeClr val="accent1">
+              <a:shade val="50000"/>
+            </a:schemeClr>
+          </a:lnRef>
+          <a:fillRef idx="1">
+            <a:schemeClr val="accent1"/>
+          </a:fillRef>
+          <a:effectRef idx="0">
+            <a:schemeClr val="accent1"/>
+          </a:effectRef>
+          <a:fontRef idx="minor">
+            <a:schemeClr val="lt1"/>
+          </a:fontRef>
+        </p:style>
         <p:txBody>
-          <a:bodyPr/>
+          <a:bodyPr rtlCol="0" anchor="ctr"/>
           <a:lstStyle/>
           <a:p>
-            <a:endParaRPr lang="en-GB"/>
+            <a:pPr algn="ctr"/>
+            <a:r>
+              <a:rPr lang="en-IE" dirty="0">
+                <a:solidFill>
+                  <a:schemeClr val="tx1"/>
+                </a:solidFill>
+              </a:rPr>
+              <a:t>Add the two new methods but throw an ‘Not Implemented Exception’</a:t>
+            </a:r>
           </a:p>
         </p:txBody>
       </p:sp>
-      <p:sp>
-        <p:nvSpPr>
-          <p:cNvPr id="3" name="Text Placeholder 2">
-            <a:extLst>
-              <a:ext uri="{FF2B5EF4-FFF2-40B4-BE49-F238E27FC236}">
-                <a16:creationId xmlns:a16="http://schemas.microsoft.com/office/drawing/2014/main" id="{E5ADF57A-3FA8-B6FE-5EBB-B398E2D10466}"/>
-              </a:ext>
-            </a:extLst>
-          </p:cNvPr>
-          <p:cNvSpPr>
-            <a:spLocks noGrp="1"/>
-          </p:cNvSpPr>
-          <p:nvPr>
-            <p:ph type="body" idx="1"/>
-          </p:nvPr>
-        </p:nvSpPr>
-        <p:spPr/>
-        <p:txBody>
-          <a:bodyPr/>
-          <a:lstStyle/>
-          <a:p>
-            <a:endParaRPr lang="en-GB"/>
-          </a:p>
-        </p:txBody>
-      </p:sp>
+      <p:cxnSp>
+        <p:nvCxnSpPr>
+          <p:cNvPr id="12" name="Straight Arrow Connector 11">
+            <a:extLst>
+              <a:ext uri="{FF2B5EF4-FFF2-40B4-BE49-F238E27FC236}">
+                <a16:creationId xmlns:a16="http://schemas.microsoft.com/office/drawing/2014/main" id="{56BFEA6A-9607-2A81-E9C4-CF6AF022A8E7}"/>
+              </a:ext>
+            </a:extLst>
+          </p:cNvPr>
+          <p:cNvCxnSpPr>
+            <a:cxnSpLocks/>
+          </p:cNvCxnSpPr>
+          <p:nvPr/>
+        </p:nvCxnSpPr>
+        <p:spPr>
+          <a:xfrm flipH="1">
+            <a:off x="4254366" y="4379495"/>
+            <a:ext cx="2290813" cy="0"/>
+          </a:xfrm>
+          <a:prstGeom prst="straightConnector1">
+            <a:avLst/>
+          </a:prstGeom>
+          <a:ln>
+            <a:tailEnd type="triangle"/>
+          </a:ln>
+        </p:spPr>
+        <p:style>
+          <a:lnRef idx="1">
+            <a:schemeClr val="accent1"/>
+          </a:lnRef>
+          <a:fillRef idx="0">
+            <a:schemeClr val="accent1"/>
+          </a:fillRef>
+          <a:effectRef idx="0">
+            <a:schemeClr val="accent1"/>
+          </a:effectRef>
+          <a:fontRef idx="minor">
+            <a:schemeClr val="tx1"/>
+          </a:fontRef>
+        </p:style>
+      </p:cxnSp>
+      <p:cxnSp>
+        <p:nvCxnSpPr>
+          <p:cNvPr id="13" name="Straight Arrow Connector 12">
+            <a:extLst>
+              <a:ext uri="{FF2B5EF4-FFF2-40B4-BE49-F238E27FC236}">
+                <a16:creationId xmlns:a16="http://schemas.microsoft.com/office/drawing/2014/main" id="{257ACE3D-14E0-520D-04D4-D7FDC67B3FB7}"/>
+              </a:ext>
+            </a:extLst>
+          </p:cNvPr>
+          <p:cNvCxnSpPr>
+            <a:cxnSpLocks/>
+          </p:cNvCxnSpPr>
+          <p:nvPr/>
+        </p:nvCxnSpPr>
+        <p:spPr>
+          <a:xfrm flipH="1">
+            <a:off x="6225941" y="4849528"/>
+            <a:ext cx="949693" cy="0"/>
+          </a:xfrm>
+          <a:prstGeom prst="straightConnector1">
+            <a:avLst/>
+          </a:prstGeom>
+          <a:ln>
+            <a:tailEnd type="triangle"/>
+          </a:ln>
+        </p:spPr>
+        <p:style>
+          <a:lnRef idx="1">
+            <a:schemeClr val="accent1"/>
+          </a:lnRef>
+          <a:fillRef idx="0">
+            <a:schemeClr val="accent1"/>
+          </a:fillRef>
+          <a:effectRef idx="0">
+            <a:schemeClr val="accent1"/>
+          </a:effectRef>
+          <a:fontRef idx="minor">
+            <a:schemeClr val="tx1"/>
+          </a:fontRef>
+        </p:style>
+      </p:cxnSp>
     </p:spTree>
     <p:extLst>
       <p:ext uri="{BB962C8B-B14F-4D97-AF65-F5344CB8AC3E}">
@@ -7468,60 +8030,250 @@
           <a:chExt cx="0" cy="0"/>
         </a:xfrm>
       </p:grpSpPr>
-      <p:sp>
-        <p:nvSpPr>
-          <p:cNvPr id="2" name="Title 1">
-            <a:extLst>
-              <a:ext uri="{FF2B5EF4-FFF2-40B4-BE49-F238E27FC236}">
-                <a16:creationId xmlns:a16="http://schemas.microsoft.com/office/drawing/2014/main" id="{88CABA1B-FB23-971D-1CB2-5225504941AB}"/>
-              </a:ext>
-            </a:extLst>
-          </p:cNvPr>
-          <p:cNvSpPr>
-            <a:spLocks noGrp="1"/>
-          </p:cNvSpPr>
-          <p:nvPr>
-            <p:ph type="title"/>
-          </p:nvPr>
-        </p:nvSpPr>
-        <p:spPr/>
-        <p:txBody>
-          <a:bodyPr/>
-          <a:lstStyle/>
-          <a:p>
-            <a:endParaRPr lang="en-GB"/>
-          </a:p>
-        </p:txBody>
-      </p:sp>
-      <p:sp>
-        <p:nvSpPr>
-          <p:cNvPr id="3" name="Text Placeholder 2">
-            <a:extLst>
-              <a:ext uri="{FF2B5EF4-FFF2-40B4-BE49-F238E27FC236}">
-                <a16:creationId xmlns:a16="http://schemas.microsoft.com/office/drawing/2014/main" id="{F51FC2B8-AD28-6B87-9822-7E7A55C488D2}"/>
-              </a:ext>
-            </a:extLst>
-          </p:cNvPr>
-          <p:cNvSpPr>
-            <a:spLocks noGrp="1"/>
-          </p:cNvSpPr>
-          <p:nvPr>
-            <p:ph type="body" idx="1"/>
-          </p:nvPr>
-        </p:nvSpPr>
-        <p:spPr/>
-        <p:txBody>
-          <a:bodyPr/>
-          <a:lstStyle/>
-          <a:p>
-            <a:endParaRPr lang="en-GB"/>
-          </a:p>
-        </p:txBody>
-      </p:sp>
+      <p:pic>
+        <p:nvPicPr>
+          <p:cNvPr id="5" name="Picture 4">
+            <a:extLst>
+              <a:ext uri="{FF2B5EF4-FFF2-40B4-BE49-F238E27FC236}">
+                <a16:creationId xmlns:a16="http://schemas.microsoft.com/office/drawing/2014/main" id="{764D1CEC-E4E6-7374-3C86-92BC2DB28255}"/>
+              </a:ext>
+            </a:extLst>
+          </p:cNvPr>
+          <p:cNvPicPr>
+            <a:picLocks noChangeAspect="1"/>
+          </p:cNvPicPr>
+          <p:nvPr/>
+        </p:nvPicPr>
+        <p:blipFill>
+          <a:blip r:embed="rId2"/>
+          <a:stretch>
+            <a:fillRect/>
+          </a:stretch>
+        </p:blipFill>
+        <p:spPr>
+          <a:xfrm>
+            <a:off x="1217251" y="1870430"/>
+            <a:ext cx="9757498" cy="2922951"/>
+          </a:xfrm>
+          <a:prstGeom prst="rect">
+            <a:avLst/>
+          </a:prstGeom>
+        </p:spPr>
+      </p:pic>
     </p:spTree>
     <p:extLst>
       <p:ext uri="{BB962C8B-B14F-4D97-AF65-F5344CB8AC3E}">
         <p14:creationId xmlns:p14="http://schemas.microsoft.com/office/powerpoint/2010/main" val="3808289765"/>
+      </p:ext>
+    </p:extLst>
+  </p:cSld>
+  <p:clrMapOvr>
+    <a:masterClrMapping/>
+  </p:clrMapOvr>
+</p:sld>
+</file>
+
+<file path=ppt/slides/slide44.xml><?xml version="1.0" encoding="utf-8"?>
+<p:sld xmlns:a="http://schemas.openxmlformats.org/drawingml/2006/main" xmlns:r="http://schemas.openxmlformats.org/officeDocument/2006/relationships" xmlns:p="http://schemas.openxmlformats.org/presentationml/2006/main">
+  <p:cSld>
+    <p:spTree>
+      <p:nvGrpSpPr>
+        <p:cNvPr id="1" name=""/>
+        <p:cNvGrpSpPr/>
+        <p:nvPr/>
+      </p:nvGrpSpPr>
+      <p:grpSpPr>
+        <a:xfrm>
+          <a:off x="0" y="0"/>
+          <a:ext cx="0" cy="0"/>
+          <a:chOff x="0" y="0"/>
+          <a:chExt cx="0" cy="0"/>
+        </a:xfrm>
+      </p:grpSpPr>
+      <p:pic>
+        <p:nvPicPr>
+          <p:cNvPr id="3" name="Picture 2">
+            <a:extLst>
+              <a:ext uri="{FF2B5EF4-FFF2-40B4-BE49-F238E27FC236}">
+                <a16:creationId xmlns:a16="http://schemas.microsoft.com/office/drawing/2014/main" id="{9E135F79-0A20-4A52-FEE0-542DB805A60C}"/>
+              </a:ext>
+            </a:extLst>
+          </p:cNvPr>
+          <p:cNvPicPr>
+            <a:picLocks noChangeAspect="1"/>
+          </p:cNvPicPr>
+          <p:nvPr/>
+        </p:nvPicPr>
+        <p:blipFill>
+          <a:blip r:embed="rId2"/>
+          <a:stretch>
+            <a:fillRect/>
+          </a:stretch>
+        </p:blipFill>
+        <p:spPr>
+          <a:xfrm>
+            <a:off x="619809" y="1843285"/>
+            <a:ext cx="10952381" cy="3171429"/>
+          </a:xfrm>
+          <a:prstGeom prst="rect">
+            <a:avLst/>
+          </a:prstGeom>
+        </p:spPr>
+      </p:pic>
+    </p:spTree>
+    <p:extLst>
+      <p:ext uri="{BB962C8B-B14F-4D97-AF65-F5344CB8AC3E}">
+        <p14:creationId xmlns:p14="http://schemas.microsoft.com/office/powerpoint/2010/main" val="2634191447"/>
+      </p:ext>
+    </p:extLst>
+  </p:cSld>
+  <p:clrMapOvr>
+    <a:masterClrMapping/>
+  </p:clrMapOvr>
+</p:sld>
+</file>
+
+<file path=ppt/slides/slide45.xml><?xml version="1.0" encoding="utf-8"?>
+<p:sld xmlns:a="http://schemas.openxmlformats.org/drawingml/2006/main" xmlns:r="http://schemas.openxmlformats.org/officeDocument/2006/relationships" xmlns:p="http://schemas.openxmlformats.org/presentationml/2006/main">
+  <p:cSld>
+    <p:spTree>
+      <p:nvGrpSpPr>
+        <p:cNvPr id="1" name=""/>
+        <p:cNvGrpSpPr/>
+        <p:nvPr/>
+      </p:nvGrpSpPr>
+      <p:grpSpPr>
+        <a:xfrm>
+          <a:off x="0" y="0"/>
+          <a:ext cx="0" cy="0"/>
+          <a:chOff x="0" y="0"/>
+          <a:chExt cx="0" cy="0"/>
+        </a:xfrm>
+      </p:grpSpPr>
+    </p:spTree>
+    <p:extLst>
+      <p:ext uri="{BB962C8B-B14F-4D97-AF65-F5344CB8AC3E}">
+        <p14:creationId xmlns:p14="http://schemas.microsoft.com/office/powerpoint/2010/main" val="3653207458"/>
+      </p:ext>
+    </p:extLst>
+  </p:cSld>
+  <p:clrMapOvr>
+    <a:masterClrMapping/>
+  </p:clrMapOvr>
+</p:sld>
+</file>
+
+<file path=ppt/slides/slide46.xml><?xml version="1.0" encoding="utf-8"?>
+<p:sld xmlns:a="http://schemas.openxmlformats.org/drawingml/2006/main" xmlns:r="http://schemas.openxmlformats.org/officeDocument/2006/relationships" xmlns:p="http://schemas.openxmlformats.org/presentationml/2006/main">
+  <p:cSld>
+    <p:spTree>
+      <p:nvGrpSpPr>
+        <p:cNvPr id="1" name=""/>
+        <p:cNvGrpSpPr/>
+        <p:nvPr/>
+      </p:nvGrpSpPr>
+      <p:grpSpPr>
+        <a:xfrm>
+          <a:off x="0" y="0"/>
+          <a:ext cx="0" cy="0"/>
+          <a:chOff x="0" y="0"/>
+          <a:chExt cx="0" cy="0"/>
+        </a:xfrm>
+      </p:grpSpPr>
+    </p:spTree>
+    <p:extLst>
+      <p:ext uri="{BB962C8B-B14F-4D97-AF65-F5344CB8AC3E}">
+        <p14:creationId xmlns:p14="http://schemas.microsoft.com/office/powerpoint/2010/main" val="3983423945"/>
+      </p:ext>
+    </p:extLst>
+  </p:cSld>
+  <p:clrMapOvr>
+    <a:masterClrMapping/>
+  </p:clrMapOvr>
+</p:sld>
+</file>
+
+<file path=ppt/slides/slide47.xml><?xml version="1.0" encoding="utf-8"?>
+<p:sld xmlns:a="http://schemas.openxmlformats.org/drawingml/2006/main" xmlns:r="http://schemas.openxmlformats.org/officeDocument/2006/relationships" xmlns:p="http://schemas.openxmlformats.org/presentationml/2006/main">
+  <p:cSld>
+    <p:spTree>
+      <p:nvGrpSpPr>
+        <p:cNvPr id="1" name=""/>
+        <p:cNvGrpSpPr/>
+        <p:nvPr/>
+      </p:nvGrpSpPr>
+      <p:grpSpPr>
+        <a:xfrm>
+          <a:off x="0" y="0"/>
+          <a:ext cx="0" cy="0"/>
+          <a:chOff x="0" y="0"/>
+          <a:chExt cx="0" cy="0"/>
+        </a:xfrm>
+      </p:grpSpPr>
+    </p:spTree>
+    <p:extLst>
+      <p:ext uri="{BB962C8B-B14F-4D97-AF65-F5344CB8AC3E}">
+        <p14:creationId xmlns:p14="http://schemas.microsoft.com/office/powerpoint/2010/main" val="2627098666"/>
+      </p:ext>
+    </p:extLst>
+  </p:cSld>
+  <p:clrMapOvr>
+    <a:masterClrMapping/>
+  </p:clrMapOvr>
+</p:sld>
+</file>
+
+<file path=ppt/slides/slide48.xml><?xml version="1.0" encoding="utf-8"?>
+<p:sld xmlns:a="http://schemas.openxmlformats.org/drawingml/2006/main" xmlns:r="http://schemas.openxmlformats.org/officeDocument/2006/relationships" xmlns:p="http://schemas.openxmlformats.org/presentationml/2006/main">
+  <p:cSld>
+    <p:spTree>
+      <p:nvGrpSpPr>
+        <p:cNvPr id="1" name=""/>
+        <p:cNvGrpSpPr/>
+        <p:nvPr/>
+      </p:nvGrpSpPr>
+      <p:grpSpPr>
+        <a:xfrm>
+          <a:off x="0" y="0"/>
+          <a:ext cx="0" cy="0"/>
+          <a:chOff x="0" y="0"/>
+          <a:chExt cx="0" cy="0"/>
+        </a:xfrm>
+      </p:grpSpPr>
+    </p:spTree>
+    <p:extLst>
+      <p:ext uri="{BB962C8B-B14F-4D97-AF65-F5344CB8AC3E}">
+        <p14:creationId xmlns:p14="http://schemas.microsoft.com/office/powerpoint/2010/main" val="2353242281"/>
+      </p:ext>
+    </p:extLst>
+  </p:cSld>
+  <p:clrMapOvr>
+    <a:masterClrMapping/>
+  </p:clrMapOvr>
+</p:sld>
+</file>
+
+<file path=ppt/slides/slide49.xml><?xml version="1.0" encoding="utf-8"?>
+<p:sld xmlns:a="http://schemas.openxmlformats.org/drawingml/2006/main" xmlns:r="http://schemas.openxmlformats.org/officeDocument/2006/relationships" xmlns:p="http://schemas.openxmlformats.org/presentationml/2006/main">
+  <p:cSld>
+    <p:spTree>
+      <p:nvGrpSpPr>
+        <p:cNvPr id="1" name=""/>
+        <p:cNvGrpSpPr/>
+        <p:nvPr/>
+      </p:nvGrpSpPr>
+      <p:grpSpPr>
+        <a:xfrm>
+          <a:off x="0" y="0"/>
+          <a:ext cx="0" cy="0"/>
+          <a:chOff x="0" y="0"/>
+          <a:chExt cx="0" cy="0"/>
+        </a:xfrm>
+      </p:grpSpPr>
+    </p:spTree>
+    <p:extLst>
+      <p:ext uri="{BB962C8B-B14F-4D97-AF65-F5344CB8AC3E}">
+        <p14:creationId xmlns:p14="http://schemas.microsoft.com/office/powerpoint/2010/main" val="3208859128"/>
       </p:ext>
     </p:extLst>
   </p:cSld>
@@ -7582,6 +8334,66 @@
     <p:extLst>
       <p:ext uri="{BB962C8B-B14F-4D97-AF65-F5344CB8AC3E}">
         <p14:creationId xmlns:p14="http://schemas.microsoft.com/office/powerpoint/2010/main" val="2445765700"/>
+      </p:ext>
+    </p:extLst>
+  </p:cSld>
+  <p:clrMapOvr>
+    <a:masterClrMapping/>
+  </p:clrMapOvr>
+</p:sld>
+</file>
+
+<file path=ppt/slides/slide50.xml><?xml version="1.0" encoding="utf-8"?>
+<p:sld xmlns:a="http://schemas.openxmlformats.org/drawingml/2006/main" xmlns:r="http://schemas.openxmlformats.org/officeDocument/2006/relationships" xmlns:p="http://schemas.openxmlformats.org/presentationml/2006/main">
+  <p:cSld>
+    <p:spTree>
+      <p:nvGrpSpPr>
+        <p:cNvPr id="1" name=""/>
+        <p:cNvGrpSpPr/>
+        <p:nvPr/>
+      </p:nvGrpSpPr>
+      <p:grpSpPr>
+        <a:xfrm>
+          <a:off x="0" y="0"/>
+          <a:ext cx="0" cy="0"/>
+          <a:chOff x="0" y="0"/>
+          <a:chExt cx="0" cy="0"/>
+        </a:xfrm>
+      </p:grpSpPr>
+    </p:spTree>
+    <p:extLst>
+      <p:ext uri="{BB962C8B-B14F-4D97-AF65-F5344CB8AC3E}">
+        <p14:creationId xmlns:p14="http://schemas.microsoft.com/office/powerpoint/2010/main" val="4076882749"/>
+      </p:ext>
+    </p:extLst>
+  </p:cSld>
+  <p:clrMapOvr>
+    <a:masterClrMapping/>
+  </p:clrMapOvr>
+</p:sld>
+</file>
+
+<file path=ppt/slides/slide51.xml><?xml version="1.0" encoding="utf-8"?>
+<p:sld xmlns:a="http://schemas.openxmlformats.org/drawingml/2006/main" xmlns:r="http://schemas.openxmlformats.org/officeDocument/2006/relationships" xmlns:p="http://schemas.openxmlformats.org/presentationml/2006/main">
+  <p:cSld>
+    <p:spTree>
+      <p:nvGrpSpPr>
+        <p:cNvPr id="1" name=""/>
+        <p:cNvGrpSpPr/>
+        <p:nvPr/>
+      </p:nvGrpSpPr>
+      <p:grpSpPr>
+        <a:xfrm>
+          <a:off x="0" y="0"/>
+          <a:ext cx="0" cy="0"/>
+          <a:chOff x="0" y="0"/>
+          <a:chExt cx="0" cy="0"/>
+        </a:xfrm>
+      </p:grpSpPr>
+    </p:spTree>
+    <p:extLst>
+      <p:ext uri="{BB962C8B-B14F-4D97-AF65-F5344CB8AC3E}">
+        <p14:creationId xmlns:p14="http://schemas.microsoft.com/office/powerpoint/2010/main" val="4098131677"/>
       </p:ext>
     </p:extLst>
   </p:cSld>

</xml_diff>